<commit_message>
Klasse 9: generierte Ausgabe-Dateien aus PR entfernen
</commit_message>
<xml_diff>
--- a/Ausgabe/Klasse_8/02_Algorithmen/05_Praesentationen/01_02_Algorithmen.pptx
+++ b/Ausgabe/Klasse_8/02_Algorithmen/05_Praesentationen/01_02_Algorithmen.pptx
@@ -14,6 +14,7 @@
     <p:sldId id="262" r:id="rId14"/>
     <p:sldId id="263" r:id="rId15"/>
     <p:sldId id="264" r:id="rId16"/>
+    <p:sldId id="265" r:id="rId17"/>
   </p:sldIdLst>
   <p:sldSz cx="12191695" cy="6858000" type="screen4x3"/>
   <p:notesSz cx="6858000" cy="9144000"/>
@@ -510,7 +511,77 @@
           <a:lstStyle/>
           <a:p>
             <a:r>
-              <a:t>Lehrplan: https://www.schulportal.sachsen.de/lplandb/lehrplan/514</a:t>
+              <a:t>Lehrplanbezug: https://www.schulportal.sachsen.de/lplandb/lehrplan/514</a:t>
+            </a:r>
+          </a:p>
+        </p:txBody>
+      </p:sp>
+      <p:sp>
+        <p:nvSpPr>
+          <p:cNvPr id="4" name="Slide Number Placeholder 3"/>
+          <p:cNvSpPr>
+            <a:spLocks noGrp="1"/>
+          </p:cNvSpPr>
+          <p:nvPr>
+            <p:ph type="sldNum" idx="5" sz="quarter"/>
+          </p:nvPr>
+        </p:nvSpPr>
+        <p:spPr/>
+      </p:sp>
+    </p:spTree>
+  </p:cSld>
+  <p:clrMapOvr>
+    <a:masterClrMapping/>
+  </p:clrMapOvr>
+</p:notes>
+</file>
+
+<file path=ppt/notesSlides/notesSlide10.xml><?xml version="1.0" encoding="utf-8"?>
+<p:notes xmlns:a="http://schemas.openxmlformats.org/drawingml/2006/main" xmlns:p="http://schemas.openxmlformats.org/presentationml/2006/main" xmlns:r="http://schemas.openxmlformats.org/officeDocument/2006/relationships">
+  <p:cSld>
+    <p:spTree>
+      <p:nvGrpSpPr>
+        <p:cNvPr id="1" name=""/>
+        <p:cNvGrpSpPr/>
+        <p:nvPr/>
+      </p:nvGrpSpPr>
+      <p:grpSpPr>
+        <a:xfrm>
+          <a:off x="0" y="0"/>
+          <a:ext cx="0" cy="0"/>
+          <a:chOff x="0" y="0"/>
+          <a:chExt cx="0" cy="0"/>
+        </a:xfrm>
+      </p:grpSpPr>
+      <p:sp>
+        <p:nvSpPr>
+          <p:cNvPr id="2" name="Slide Image Placeholder 1"/>
+          <p:cNvSpPr>
+            <a:spLocks noGrp="1"/>
+          </p:cNvSpPr>
+          <p:nvPr>
+            <p:ph type="sldImg" idx="2"/>
+          </p:nvPr>
+        </p:nvSpPr>
+        <p:spPr/>
+      </p:sp>
+      <p:sp>
+        <p:nvSpPr>
+          <p:cNvPr id="3" name="Notes Placeholder 2"/>
+          <p:cNvSpPr>
+            <a:spLocks noGrp="1"/>
+          </p:cNvSpPr>
+          <p:nvPr>
+            <p:ph type="body" idx="3" sz="quarter"/>
+          </p:nvPr>
+        </p:nvSpPr>
+        <p:spPr/>
+        <p:txBody>
+          <a:bodyPr/>
+          <a:lstStyle/>
+          <a:p>
+            <a:r>
+              <a:t>Quellenfolie. Keine internen Repository-, Branch- oder Markdown-Verweise in der Schülerpräsentation.</a:t>
             </a:r>
           </a:p>
         </p:txBody>
@@ -580,7 +651,7 @@
           <a:lstStyle/>
           <a:p>
             <a:r>
-              <a:t>Mit ungenauen Alltagsschritten starten und präzisieren.</a:t>
+              <a:t>Mit absichtlich unklaren Anweisungen starten. Ziel: Kriterien eines Algorithmus aus Beispielen ableiten.</a:t>
             </a:r>
           </a:p>
         </p:txBody>
@@ -650,7 +721,7 @@
           <a:lstStyle/>
           <a:p>
             <a:r>
-              <a:t>Ergänzung in endlicher Zeit explizit nennen.</a:t>
+              <a:t>Definition altersgerecht einführen. Alltag und Informatik verbinden.</a:t>
             </a:r>
           </a:p>
         </p:txBody>
@@ -720,7 +791,7 @@
           <a:lstStyle/>
           <a:p>
             <a:r>
-              <a:t>Struktogramm als Darstellungsform erläutern.</a:t>
+              <a:t>Die vom Nutzer gewünschte Ergänzung 'in endlicher Zeit' ausdrücklich thematisieren. Beispiele und Gegenbeispiele sammeln.</a:t>
             </a:r>
           </a:p>
         </p:txBody>
@@ -790,7 +861,7 @@
           <a:lstStyle/>
           <a:p>
             <a:r>
-              <a:t>Abkürzungen vermeiden; Schülerbeispiele sammeln.</a:t>
+              <a:t>Begriff Struktogramm neu einführen. Ein Nassi-Shneiderman-Struktogramm zeigt Kontrollstrukturen durch ineinander liegende Blöcke. Noch keine komplexe Verschachtelung.</a:t>
             </a:r>
           </a:p>
         </p:txBody>
@@ -860,7 +931,7 @@
           <a:lstStyle/>
           <a:p>
             <a:r>
-              <a:t>Robot-Karol-Beispiele konkret besprechen.</a:t>
+              <a:t>Mehrere Beispiele nutzen: Alltag, Anmeldung, Spiel, Karol. Fachhinweis: if wertet eine Bedingung wahr/falsch aus. Mehrfachauswahlen wie switch/case sind andere Auswahlstrukturen und werden hier nicht benötigt.</a:t>
             </a:r>
           </a:p>
         </p:txBody>
@@ -930,7 +1001,7 @@
           <a:lstStyle/>
           <a:p>
             <a:r>
-              <a:t>Arbeitsblatt soll Verschachtelung enthalten.</a:t>
+              <a:t>Konkrete Karol-Beispiele ankündigen. Unterschied nicht nur definieren, sondern an Aufgaben entscheiden lassen.</a:t>
             </a:r>
           </a:p>
         </p:txBody>
@@ -1000,7 +1071,7 @@
           <a:lstStyle/>
           <a:p>
             <a:r>
-              <a:t>Nicht nur Seitenlänge 1; konkrete Szenarien verwenden.</a:t>
+              <a:t>Verschachtelung als allgemeines Konzept erklären. Arbeitsblatt sollte Aufgaben zu Code, Struktogramm und Ablauf enthalten.</a:t>
             </a:r>
           </a:p>
         </p:txBody>
@@ -1070,7 +1141,7 @@
           <a:lstStyle/>
           <a:p>
             <a:r>
-              <a:t>Quellenfolie. Quellenangaben sind für Lehrkraft/Weiterverwendung sichtbar.</a:t>
+              <a:t>Testfälle als kleine Szenarien formulieren, nicht nur 'Seitenlänge 1'. Normal-, Rand- und Sonderfall anhand konkreter Welten üben.</a:t>
             </a:r>
           </a:p>
         </p:txBody>
@@ -4091,7 +4162,7 @@
             <a:avLst/>
           </a:prstGeom>
           <a:solidFill>
-            <a:srgbClr val="202C3C"/>
+            <a:srgbClr val="1F374E"/>
           </a:solidFill>
           <a:ln>
             <a:noFill/>
@@ -4127,8 +4198,8 @@
         </p:nvSpPr>
         <p:spPr>
           <a:xfrm>
-            <a:off x="731520" y="1554480"/>
-            <a:ext cx="10789920" cy="1097280"/>
+            <a:off x="731520" y="1417320"/>
+            <a:ext cx="10698480" cy="1188720"/>
           </a:xfrm>
           <a:prstGeom prst="rect">
             <a:avLst/>
@@ -4160,8 +4231,8 @@
         </p:nvSpPr>
         <p:spPr>
           <a:xfrm>
-            <a:off x="777240" y="3017520"/>
-            <a:ext cx="10515600" cy="640080"/>
+            <a:off x="777240" y="2971800"/>
+            <a:ext cx="10515600" cy="731520"/>
           </a:xfrm>
           <a:prstGeom prst="rect">
             <a:avLst/>
@@ -4180,7 +4251,188 @@
                   <a:srgbClr val="FFFFFF"/>
                 </a:solidFill>
               </a:rPr>
-              <a:t>Klasse 8 · Darstellen, Prüfen, Begründen</a:t>
+              <a:t>Klasse 8 · Algorithmen und Programme</a:t>
+            </a:r>
+          </a:p>
+        </p:txBody>
+      </p:sp>
+    </p:spTree>
+  </p:cSld>
+  <p:clrMapOvr>
+    <a:masterClrMapping/>
+  </p:clrMapOvr>
+</p:sld>
+</file>
+
+<file path=ppt/slides/slide10.xml><?xml version="1.0" encoding="utf-8"?>
+<p:sld xmlns:a="http://schemas.openxmlformats.org/drawingml/2006/main" xmlns:p="http://schemas.openxmlformats.org/presentationml/2006/main" xmlns:r="http://schemas.openxmlformats.org/officeDocument/2006/relationships">
+  <p:cSld>
+    <p:spTree>
+      <p:nvGrpSpPr>
+        <p:cNvPr id="1" name=""/>
+        <p:cNvGrpSpPr/>
+        <p:nvPr/>
+      </p:nvGrpSpPr>
+      <p:grpSpPr/>
+      <p:sp>
+        <p:nvSpPr>
+          <p:cNvPr id="2" name="Rectangle 1"/>
+          <p:cNvSpPr/>
+          <p:nvPr/>
+        </p:nvSpPr>
+        <p:spPr>
+          <a:xfrm>
+            <a:off x="0" y="0"/>
+            <a:ext cx="12191695" cy="100584"/>
+          </a:xfrm>
+          <a:prstGeom prst="rect">
+            <a:avLst/>
+          </a:prstGeom>
+          <a:solidFill>
+            <a:srgbClr val="4472C4"/>
+          </a:solidFill>
+          <a:ln>
+            <a:noFill/>
+          </a:ln>
+        </p:spPr>
+        <p:style>
+          <a:lnRef idx="1">
+            <a:schemeClr val="accent1"/>
+          </a:lnRef>
+          <a:fillRef idx="3">
+            <a:schemeClr val="accent1"/>
+          </a:fillRef>
+          <a:effectRef idx="2">
+            <a:schemeClr val="accent1"/>
+          </a:effectRef>
+          <a:fontRef idx="minor">
+            <a:schemeClr val="lt1"/>
+          </a:fontRef>
+        </p:style>
+        <p:txBody>
+          <a:bodyPr rtlCol="0" anchor="ctr"/>
+          <a:lstStyle/>
+          <a:p>
+            <a:pPr algn="ctr"/>
+          </a:p>
+        </p:txBody>
+      </p:sp>
+      <p:sp>
+        <p:nvSpPr>
+          <p:cNvPr id="3" name="TextBox 2"/>
+          <p:cNvSpPr txBox="1"/>
+          <p:nvPr/>
+        </p:nvSpPr>
+        <p:spPr>
+          <a:xfrm>
+            <a:off x="594360" y="320040"/>
+            <a:ext cx="10972800" cy="502920"/>
+          </a:xfrm>
+          <a:prstGeom prst="rect">
+            <a:avLst/>
+          </a:prstGeom>
+          <a:noFill/>
+        </p:spPr>
+        <p:txBody>
+          <a:bodyPr wrap="none">
+            <a:spAutoFit/>
+          </a:bodyPr>
+          <a:lstStyle/>
+          <a:p>
+            <a:r>
+              <a:rPr sz="2600" b="1">
+                <a:solidFill>
+                  <a:srgbClr val="1F374E"/>
+                </a:solidFill>
+              </a:rPr>
+              <a:t>Quellen</a:t>
+            </a:r>
+          </a:p>
+        </p:txBody>
+      </p:sp>
+      <p:sp>
+        <p:nvSpPr>
+          <p:cNvPr id="4" name="TextBox 3"/>
+          <p:cNvSpPr txBox="1"/>
+          <p:nvPr/>
+        </p:nvSpPr>
+        <p:spPr>
+          <a:xfrm>
+            <a:off x="731520" y="1234440"/>
+            <a:ext cx="10698480" cy="5029200"/>
+          </a:xfrm>
+          <a:prstGeom prst="rect">
+            <a:avLst/>
+          </a:prstGeom>
+          <a:noFill/>
+        </p:spPr>
+        <p:txBody>
+          <a:bodyPr wrap="square">
+            <a:spAutoFit/>
+          </a:bodyPr>
+          <a:lstStyle/>
+          <a:p>
+            <a:pPr>
+              <a:spcAft>
+                <a:spcPts val="800"/>
+              </a:spcAft>
+              <a:defRPr sz="1500">
+                <a:solidFill>
+                  <a:srgbClr val="232323"/>
+                </a:solidFill>
+              </a:defRPr>
+            </a:pPr>
+            <a:r>
+              <a:t>Sächsischer Lehrplan Oberschule Informatik, Klassenstufe 8: https://www.schulportal.sachsen.de/lplandb/lehrplan/514</a:t>
+            </a:r>
+          </a:p>
+          <a:p>
+            <a:pPr>
+              <a:spcAft>
+                <a:spcPts val="800"/>
+              </a:spcAft>
+              <a:defRPr sz="1500">
+                <a:solidFill>
+                  <a:srgbClr val="232323"/>
+                </a:solidFill>
+              </a:defRPr>
+            </a:pPr>
+            <a:r>
+              <a:t>Grafiken, Struktogramme und Beispiele: eigene didaktische Darstellung.</a:t>
+            </a:r>
+          </a:p>
+        </p:txBody>
+      </p:sp>
+      <p:sp>
+        <p:nvSpPr>
+          <p:cNvPr id="5" name="TextBox 4"/>
+          <p:cNvSpPr txBox="1"/>
+          <p:nvPr/>
+        </p:nvSpPr>
+        <p:spPr>
+          <a:xfrm>
+            <a:off x="502920" y="6510528"/>
+            <a:ext cx="11064240" cy="182880"/>
+          </a:xfrm>
+          <a:prstGeom prst="rect">
+            <a:avLst/>
+          </a:prstGeom>
+          <a:noFill/>
+        </p:spPr>
+        <p:txBody>
+          <a:bodyPr wrap="none">
+            <a:spAutoFit/>
+          </a:bodyPr>
+          <a:lstStyle/>
+          <a:p>
+            <a:pPr algn="r"/>
+            <a:r>
+              <a:rPr sz="800">
+                <a:solidFill>
+                  <a:srgbClr val="646464"/>
+                </a:solidFill>
+              </a:rPr>
+              <a:t>Quellenangaben · Grafiken: eigene Darstellung</a:t>
             </a:r>
           </a:p>
         </p:txBody>
@@ -4212,13 +4464,13 @@
         <p:spPr>
           <a:xfrm>
             <a:off x="0" y="0"/>
-            <a:ext cx="12191695" cy="109728"/>
+            <a:ext cx="12191695" cy="100584"/>
           </a:xfrm>
           <a:prstGeom prst="rect">
             <a:avLst/>
           </a:prstGeom>
           <a:solidFill>
-            <a:srgbClr val="305396"/>
+            <a:srgbClr val="4472C4"/>
           </a:solidFill>
           <a:ln>
             <a:noFill/>
@@ -4255,7 +4507,7 @@
         <p:spPr>
           <a:xfrm>
             <a:off x="594360" y="320040"/>
-            <a:ext cx="10972800" cy="548640"/>
+            <a:ext cx="10972800" cy="502920"/>
           </a:xfrm>
           <a:prstGeom prst="rect">
             <a:avLst/>
@@ -4271,7 +4523,7 @@
             <a:r>
               <a:rPr sz="2600" b="1">
                 <a:solidFill>
-                  <a:srgbClr val="202C3C"/>
+                  <a:srgbClr val="1F374E"/>
                 </a:solidFill>
               </a:rPr>
               <a:t>Leitfrage</a:t>
@@ -4287,18 +4539,18 @@
         </p:nvSpPr>
         <p:spPr>
           <a:xfrm>
-            <a:off x="777240" y="1234440"/>
-            <a:ext cx="10789920" cy="1234440"/>
+            <a:off x="822960" y="1325880"/>
+            <a:ext cx="10515600" cy="1417320"/>
           </a:xfrm>
           <a:prstGeom prst="roundRect">
             <a:avLst/>
           </a:prstGeom>
           <a:solidFill>
-            <a:srgbClr val="E5ECF6"/>
+            <a:srgbClr val="DCE6F1"/>
           </a:solidFill>
           <a:ln>
             <a:solidFill>
-              <a:srgbClr val="305396"/>
+              <a:srgbClr val="4472C4"/>
             </a:solidFill>
           </a:ln>
         </p:spPr>
@@ -4322,9 +4574,9 @@
           <a:p>
             <a:pPr algn="ctr"/>
             <a:r>
-              <a:rPr sz="2200" b="1">
-                <a:solidFill>
-                  <a:srgbClr val="202C3C"/>
+              <a:rPr sz="2400" b="1">
+                <a:solidFill>
+                  <a:srgbClr val="1F374E"/>
                 </a:solidFill>
               </a:rPr>
               <a:t>Wann ist eine Beschreibung so genau, dass ein Computer sie ausführen kann?</a:t>
@@ -4334,226 +4586,14 @@
       </p:sp>
       <p:sp>
         <p:nvSpPr>
-          <p:cNvPr id="5" name="Rounded Rectangle 4"/>
-          <p:cNvSpPr/>
-          <p:nvPr/>
-        </p:nvSpPr>
-        <p:spPr>
-          <a:xfrm>
-            <a:off x="6949440" y="2743200"/>
-            <a:ext cx="3474720" cy="530352"/>
-          </a:xfrm>
-          <a:prstGeom prst="roundRect">
-            <a:avLst/>
-          </a:prstGeom>
-          <a:solidFill>
-            <a:srgbClr val="E5ECF6"/>
-          </a:solidFill>
-          <a:ln>
-            <a:solidFill>
-              <a:srgbClr val="305396"/>
-            </a:solidFill>
-          </a:ln>
-        </p:spPr>
-        <p:style>
-          <a:lnRef idx="1">
-            <a:schemeClr val="accent1"/>
-          </a:lnRef>
-          <a:fillRef idx="3">
-            <a:schemeClr val="accent1"/>
-          </a:fillRef>
-          <a:effectRef idx="2">
-            <a:schemeClr val="accent1"/>
-          </a:effectRef>
-          <a:fontRef idx="minor">
-            <a:schemeClr val="lt1"/>
-          </a:fontRef>
-        </p:style>
-        <p:txBody>
-          <a:bodyPr rtlCol="0" anchor="ctr" wrap="square"/>
-          <a:lstStyle/>
-          <a:p>
-            <a:pPr algn="ctr"/>
-            <a:r>
-              <a:rPr sz="1200" b="1">
-                <a:solidFill>
-                  <a:srgbClr val="202C3C"/>
-                </a:solidFill>
-              </a:rPr>
-              <a:t>Start</a:t>
-            </a:r>
-          </a:p>
-        </p:txBody>
-      </p:sp>
-      <p:sp>
-        <p:nvSpPr>
-          <p:cNvPr id="6" name="Rounded Rectangle 5"/>
-          <p:cNvSpPr/>
-          <p:nvPr/>
-        </p:nvSpPr>
-        <p:spPr>
-          <a:xfrm>
-            <a:off x="6949440" y="3355848"/>
-            <a:ext cx="3474720" cy="530352"/>
-          </a:xfrm>
-          <a:prstGeom prst="roundRect">
-            <a:avLst/>
-          </a:prstGeom>
-          <a:solidFill>
-            <a:srgbClr val="E5ECF6"/>
-          </a:solidFill>
-          <a:ln>
-            <a:solidFill>
-              <a:srgbClr val="305396"/>
-            </a:solidFill>
-          </a:ln>
-        </p:spPr>
-        <p:style>
-          <a:lnRef idx="1">
-            <a:schemeClr val="accent1"/>
-          </a:lnRef>
-          <a:fillRef idx="3">
-            <a:schemeClr val="accent1"/>
-          </a:fillRef>
-          <a:effectRef idx="2">
-            <a:schemeClr val="accent1"/>
-          </a:effectRef>
-          <a:fontRef idx="minor">
-            <a:schemeClr val="lt1"/>
-          </a:fontRef>
-        </p:style>
-        <p:txBody>
-          <a:bodyPr rtlCol="0" anchor="ctr" wrap="square"/>
-          <a:lstStyle/>
-          <a:p>
-            <a:pPr algn="ctr"/>
-            <a:r>
-              <a:rPr sz="1200" b="1">
-                <a:solidFill>
-                  <a:srgbClr val="202C3C"/>
-                </a:solidFill>
-              </a:rPr>
-              <a:t>Schritt 1</a:t>
-            </a:r>
-          </a:p>
-        </p:txBody>
-      </p:sp>
-      <p:sp>
-        <p:nvSpPr>
-          <p:cNvPr id="7" name="Rounded Rectangle 6"/>
-          <p:cNvSpPr/>
-          <p:nvPr/>
-        </p:nvSpPr>
-        <p:spPr>
-          <a:xfrm>
-            <a:off x="6949440" y="3968496"/>
-            <a:ext cx="3474720" cy="530352"/>
-          </a:xfrm>
-          <a:prstGeom prst="roundRect">
-            <a:avLst/>
-          </a:prstGeom>
-          <a:solidFill>
-            <a:srgbClr val="E5ECF6"/>
-          </a:solidFill>
-          <a:ln>
-            <a:solidFill>
-              <a:srgbClr val="305396"/>
-            </a:solidFill>
-          </a:ln>
-        </p:spPr>
-        <p:style>
-          <a:lnRef idx="1">
-            <a:schemeClr val="accent1"/>
-          </a:lnRef>
-          <a:fillRef idx="3">
-            <a:schemeClr val="accent1"/>
-          </a:fillRef>
-          <a:effectRef idx="2">
-            <a:schemeClr val="accent1"/>
-          </a:effectRef>
-          <a:fontRef idx="minor">
-            <a:schemeClr val="lt1"/>
-          </a:fontRef>
-        </p:style>
-        <p:txBody>
-          <a:bodyPr rtlCol="0" anchor="ctr" wrap="square"/>
-          <a:lstStyle/>
-          <a:p>
-            <a:pPr algn="ctr"/>
-            <a:r>
-              <a:rPr sz="1200" b="1">
-                <a:solidFill>
-                  <a:srgbClr val="202C3C"/>
-                </a:solidFill>
-              </a:rPr>
-              <a:t>Schritt 2</a:t>
-            </a:r>
-          </a:p>
-        </p:txBody>
-      </p:sp>
-      <p:sp>
-        <p:nvSpPr>
-          <p:cNvPr id="8" name="Rounded Rectangle 7"/>
-          <p:cNvSpPr/>
-          <p:nvPr/>
-        </p:nvSpPr>
-        <p:spPr>
-          <a:xfrm>
-            <a:off x="6949440" y="4581144"/>
-            <a:ext cx="3474720" cy="530352"/>
-          </a:xfrm>
-          <a:prstGeom prst="roundRect">
-            <a:avLst/>
-          </a:prstGeom>
-          <a:solidFill>
-            <a:srgbClr val="E5ECF6"/>
-          </a:solidFill>
-          <a:ln>
-            <a:solidFill>
-              <a:srgbClr val="305396"/>
-            </a:solidFill>
-          </a:ln>
-        </p:spPr>
-        <p:style>
-          <a:lnRef idx="1">
-            <a:schemeClr val="accent1"/>
-          </a:lnRef>
-          <a:fillRef idx="3">
-            <a:schemeClr val="accent1"/>
-          </a:fillRef>
-          <a:effectRef idx="2">
-            <a:schemeClr val="accent1"/>
-          </a:effectRef>
-          <a:fontRef idx="minor">
-            <a:schemeClr val="lt1"/>
-          </a:fontRef>
-        </p:style>
-        <p:txBody>
-          <a:bodyPr rtlCol="0" anchor="ctr" wrap="square"/>
-          <a:lstStyle/>
-          <a:p>
-            <a:pPr algn="ctr"/>
-            <a:r>
-              <a:rPr sz="1200" b="1">
-                <a:solidFill>
-                  <a:srgbClr val="202C3C"/>
-                </a:solidFill>
-              </a:rPr>
-              <a:t>Ende</a:t>
-            </a:r>
-          </a:p>
-        </p:txBody>
-      </p:sp>
-      <p:sp>
-        <p:nvSpPr>
-          <p:cNvPr id="9" name="TextBox 8"/>
+          <p:cNvPr id="5" name="TextBox 4"/>
           <p:cNvSpPr txBox="1"/>
           <p:nvPr/>
         </p:nvSpPr>
         <p:spPr>
           <a:xfrm>
-            <a:off x="365760" y="6510528"/>
-            <a:ext cx="11430000" cy="228600"/>
+            <a:off x="502920" y="6510528"/>
+            <a:ext cx="11064240" cy="182880"/>
           </a:xfrm>
           <a:prstGeom prst="rect">
             <a:avLst/>
@@ -4570,7 +4610,7 @@
             <a:r>
               <a:rPr sz="800">
                 <a:solidFill>
-                  <a:srgbClr val="6E6E6E"/>
+                  <a:srgbClr val="646464"/>
                 </a:solidFill>
               </a:rPr>
               <a:t>Grafik: eigene Darstellung</a:t>
@@ -4605,13 +4645,13 @@
         <p:spPr>
           <a:xfrm>
             <a:off x="0" y="0"/>
-            <a:ext cx="12191695" cy="109728"/>
+            <a:ext cx="12191695" cy="100584"/>
           </a:xfrm>
           <a:prstGeom prst="rect">
             <a:avLst/>
           </a:prstGeom>
           <a:solidFill>
-            <a:srgbClr val="305396"/>
+            <a:srgbClr val="4472C4"/>
           </a:solidFill>
           <a:ln>
             <a:noFill/>
@@ -4648,7 +4688,7 @@
         <p:spPr>
           <a:xfrm>
             <a:off x="594360" y="320040"/>
-            <a:ext cx="10972800" cy="548640"/>
+            <a:ext cx="10972800" cy="502920"/>
           </a:xfrm>
           <a:prstGeom prst="rect">
             <a:avLst/>
@@ -4664,10 +4704,10 @@
             <a:r>
               <a:rPr sz="2600" b="1">
                 <a:solidFill>
-                  <a:srgbClr val="202C3C"/>
+                  <a:srgbClr val="1F374E"/>
                 </a:solidFill>
               </a:rPr>
-              <a:t>Algorithmus – Merkmale</a:t>
+              <a:t>Was ist ein Algorithmus?</a:t>
             </a:r>
           </a:p>
         </p:txBody>
@@ -4681,7 +4721,7 @@
         <p:spPr>
           <a:xfrm>
             <a:off x="685800" y="1234440"/>
-            <a:ext cx="5394960" cy="5029200"/>
+            <a:ext cx="5303520" cy="4937760"/>
           </a:xfrm>
           <a:prstGeom prst="rect">
             <a:avLst/>
@@ -4696,61 +4736,46 @@
           <a:p>
             <a:pPr>
               <a:spcAft>
-                <a:spcPts val="700"/>
+                <a:spcPts val="800"/>
               </a:spcAft>
               <a:defRPr sz="1900">
                 <a:solidFill>
-                  <a:srgbClr val="1E1E1E"/>
+                  <a:srgbClr val="232323"/>
                 </a:solidFill>
               </a:defRPr>
             </a:pPr>
             <a:r>
-              <a:t>eindeutige Folge von Anweisungen</a:t>
+              <a:t>Eine eindeutige Folge ausführbarer Anweisungen.</a:t>
             </a:r>
           </a:p>
           <a:p>
             <a:pPr>
               <a:spcAft>
-                <a:spcPts val="700"/>
+                <a:spcPts val="800"/>
               </a:spcAft>
               <a:defRPr sz="1900">
                 <a:solidFill>
-                  <a:srgbClr val="1E1E1E"/>
+                  <a:srgbClr val="232323"/>
                 </a:solidFill>
               </a:defRPr>
             </a:pPr>
             <a:r>
-              <a:t>ausführbar</a:t>
+              <a:t>Er löst eine Aufgabe oder ein Problem.</a:t>
             </a:r>
           </a:p>
           <a:p>
             <a:pPr>
               <a:spcAft>
-                <a:spcPts val="700"/>
+                <a:spcPts val="800"/>
               </a:spcAft>
               <a:defRPr sz="1900">
                 <a:solidFill>
-                  <a:srgbClr val="1E1E1E"/>
+                  <a:srgbClr val="232323"/>
                 </a:solidFill>
               </a:defRPr>
             </a:pPr>
             <a:r>
-              <a:t>endlich</a:t>
-            </a:r>
-          </a:p>
-          <a:p>
-            <a:pPr>
-              <a:spcAft>
-                <a:spcPts val="700"/>
-              </a:spcAft>
-              <a:defRPr sz="1900">
-                <a:solidFill>
-                  <a:srgbClr val="1E1E1E"/>
-                </a:solidFill>
-              </a:defRPr>
-            </a:pPr>
-            <a:r>
-              <a:t>liefert ein erwartbares Ergebnis (in endlicher Zeit)</a:t>
+              <a:t>Die Schritte sind so beschrieben, dass sie nachvollzogen werden können.</a:t>
             </a:r>
           </a:p>
         </p:txBody>
@@ -4763,18 +4788,18 @@
         </p:nvSpPr>
         <p:spPr>
           <a:xfrm>
-            <a:off x="6400800" y="1371600"/>
-            <a:ext cx="2103120" cy="731520"/>
+            <a:off x="6858000" y="1143000"/>
+            <a:ext cx="3291840" cy="594360"/>
           </a:xfrm>
           <a:prstGeom prst="roundRect">
             <a:avLst/>
           </a:prstGeom>
           <a:solidFill>
-            <a:srgbClr val="E5ECF6"/>
+            <a:srgbClr val="F2F6FA"/>
           </a:solidFill>
           <a:ln>
             <a:solidFill>
-              <a:srgbClr val="305396"/>
+              <a:srgbClr val="4472C4"/>
             </a:solidFill>
           </a:ln>
         </p:spPr>
@@ -4798,12 +4823,12 @@
           <a:p>
             <a:pPr algn="ctr"/>
             <a:r>
-              <a:rPr sz="1300" b="1">
-                <a:solidFill>
-                  <a:srgbClr val="202C3C"/>
+              <a:rPr sz="1500" b="1">
+                <a:solidFill>
+                  <a:srgbClr val="1F374E"/>
                 </a:solidFill>
               </a:rPr>
-              <a:t>eindeutig</a:t>
+              <a:t>Start</a:t>
             </a:r>
           </a:p>
         </p:txBody>
@@ -4816,18 +4841,18 @@
         </p:nvSpPr>
         <p:spPr>
           <a:xfrm>
-            <a:off x="8778240" y="1371600"/>
-            <a:ext cx="2103120" cy="731520"/>
+            <a:off x="6858000" y="2103120"/>
+            <a:ext cx="3291840" cy="594360"/>
           </a:xfrm>
           <a:prstGeom prst="roundRect">
             <a:avLst/>
           </a:prstGeom>
           <a:solidFill>
-            <a:srgbClr val="FFE899"/>
+            <a:srgbClr val="DCE6F1"/>
           </a:solidFill>
           <a:ln>
             <a:solidFill>
-              <a:srgbClr val="305396"/>
+              <a:srgbClr val="4472C4"/>
             </a:solidFill>
           </a:ln>
         </p:spPr>
@@ -4851,12 +4876,12 @@
           <a:p>
             <a:pPr algn="ctr"/>
             <a:r>
-              <a:rPr sz="1300" b="1">
-                <a:solidFill>
-                  <a:srgbClr val="202C3C"/>
+              <a:rPr sz="1500" b="1">
+                <a:solidFill>
+                  <a:srgbClr val="1F374E"/>
                 </a:solidFill>
               </a:rPr>
-              <a:t>ausführbar</a:t>
+              <a:t>Anweisung 1</a:t>
             </a:r>
           </a:p>
         </p:txBody>
@@ -4869,18 +4894,18 @@
         </p:nvSpPr>
         <p:spPr>
           <a:xfrm>
-            <a:off x="6400800" y="2514600"/>
-            <a:ext cx="2103120" cy="731520"/>
+            <a:off x="6858000" y="3063240"/>
+            <a:ext cx="3291840" cy="594360"/>
           </a:xfrm>
           <a:prstGeom prst="roundRect">
             <a:avLst/>
           </a:prstGeom>
           <a:solidFill>
-            <a:srgbClr val="DDEEDD"/>
+            <a:srgbClr val="DCE6F1"/>
           </a:solidFill>
           <a:ln>
             <a:solidFill>
-              <a:srgbClr val="305396"/>
+              <a:srgbClr val="4472C4"/>
             </a:solidFill>
           </a:ln>
         </p:spPr>
@@ -4904,12 +4929,12 @@
           <a:p>
             <a:pPr algn="ctr"/>
             <a:r>
-              <a:rPr sz="1300" b="1">
-                <a:solidFill>
-                  <a:srgbClr val="202C3C"/>
+              <a:rPr sz="1500" b="1">
+                <a:solidFill>
+                  <a:srgbClr val="1F374E"/>
                 </a:solidFill>
               </a:rPr>
-              <a:t>endlich</a:t>
+              <a:t>Anweisung 2</a:t>
             </a:r>
           </a:p>
         </p:txBody>
@@ -4922,18 +4947,18 @@
         </p:nvSpPr>
         <p:spPr>
           <a:xfrm>
-            <a:off x="8778240" y="2514600"/>
-            <a:ext cx="2103120" cy="731520"/>
+            <a:off x="6858000" y="4023360"/>
+            <a:ext cx="3291840" cy="594360"/>
           </a:xfrm>
           <a:prstGeom prst="roundRect">
             <a:avLst/>
           </a:prstGeom>
           <a:solidFill>
-            <a:srgbClr val="F8CBAD"/>
+            <a:srgbClr val="F2F6FA"/>
           </a:solidFill>
           <a:ln>
             <a:solidFill>
-              <a:srgbClr val="305396"/>
+              <a:srgbClr val="4472C4"/>
             </a:solidFill>
           </a:ln>
         </p:spPr>
@@ -4957,13 +4982,12 @@
           <a:p>
             <a:pPr algn="ctr"/>
             <a:r>
-              <a:rPr sz="1300" b="1">
-                <a:solidFill>
-                  <a:srgbClr val="202C3C"/>
+              <a:rPr sz="1500" b="1">
+                <a:solidFill>
+                  <a:srgbClr val="1F374E"/>
                 </a:solidFill>
               </a:rPr>
-              <a:t>Ergebnis
-in endlicher Zeit</a:t>
+              <a:t>Ende</a:t>
             </a:r>
           </a:p>
         </p:txBody>
@@ -4976,8 +5000,8 @@
         </p:nvSpPr>
         <p:spPr>
           <a:xfrm>
-            <a:off x="365760" y="6510528"/>
-            <a:ext cx="11430000" cy="228600"/>
+            <a:off x="502920" y="6510528"/>
+            <a:ext cx="11064240" cy="182880"/>
           </a:xfrm>
           <a:prstGeom prst="rect">
             <a:avLst/>
@@ -4994,7 +5018,7 @@
             <a:r>
               <a:rPr sz="800">
                 <a:solidFill>
-                  <a:srgbClr val="6E6E6E"/>
+                  <a:srgbClr val="646464"/>
                 </a:solidFill>
               </a:rPr>
               <a:t>Grafik: eigene Darstellung</a:t>
@@ -5029,13 +5053,13 @@
         <p:spPr>
           <a:xfrm>
             <a:off x="0" y="0"/>
-            <a:ext cx="12191695" cy="109728"/>
+            <a:ext cx="12191695" cy="100584"/>
           </a:xfrm>
           <a:prstGeom prst="rect">
             <a:avLst/>
           </a:prstGeom>
           <a:solidFill>
-            <a:srgbClr val="305396"/>
+            <a:srgbClr val="4472C4"/>
           </a:solidFill>
           <a:ln>
             <a:noFill/>
@@ -5072,7 +5096,7 @@
         <p:spPr>
           <a:xfrm>
             <a:off x="594360" y="320040"/>
-            <a:ext cx="10972800" cy="548640"/>
+            <a:ext cx="10972800" cy="502920"/>
           </a:xfrm>
           <a:prstGeom prst="rect">
             <a:avLst/>
@@ -5088,10 +5112,10 @@
             <a:r>
               <a:rPr sz="2600" b="1">
                 <a:solidFill>
-                  <a:srgbClr val="202C3C"/>
+                  <a:srgbClr val="1F374E"/>
                 </a:solidFill>
               </a:rPr>
-              <a:t>Abläufe darstellen</a:t>
+              <a:t>Qualitätsmerkmale</a:t>
             </a:r>
           </a:p>
         </p:txBody>
@@ -5105,7 +5129,7 @@
         <p:spPr>
           <a:xfrm>
             <a:off x="685800" y="1234440"/>
-            <a:ext cx="5394960" cy="5029200"/>
+            <a:ext cx="5303520" cy="4937760"/>
           </a:xfrm>
           <a:prstGeom prst="rect">
             <a:avLst/>
@@ -5120,61 +5144,61 @@
           <a:p>
             <a:pPr>
               <a:spcAft>
-                <a:spcPts val="700"/>
+                <a:spcPts val="800"/>
               </a:spcAft>
               <a:defRPr sz="1900">
                 <a:solidFill>
-                  <a:srgbClr val="1E1E1E"/>
+                  <a:srgbClr val="232323"/>
                 </a:solidFill>
               </a:defRPr>
             </a:pPr>
             <a:r>
-              <a:t>nummerierte Schritte</a:t>
+              <a:t>eindeutig</a:t>
             </a:r>
           </a:p>
           <a:p>
             <a:pPr>
               <a:spcAft>
-                <a:spcPts val="700"/>
+                <a:spcPts val="800"/>
               </a:spcAft>
               <a:defRPr sz="1900">
                 <a:solidFill>
-                  <a:srgbClr val="1E1E1E"/>
+                  <a:srgbClr val="232323"/>
                 </a:solidFill>
               </a:defRPr>
             </a:pPr>
             <a:r>
-              <a:t>Pseudocode</a:t>
+              <a:t>ausführbar</a:t>
             </a:r>
           </a:p>
           <a:p>
             <a:pPr>
               <a:spcAft>
-                <a:spcPts val="700"/>
+                <a:spcPts val="800"/>
               </a:spcAft>
               <a:defRPr sz="1900">
                 <a:solidFill>
-                  <a:srgbClr val="1E1E1E"/>
+                  <a:srgbClr val="232323"/>
                 </a:solidFill>
               </a:defRPr>
             </a:pPr>
             <a:r>
-              <a:t>Struktogramm</a:t>
+              <a:t>endlich</a:t>
             </a:r>
           </a:p>
           <a:p>
             <a:pPr>
               <a:spcAft>
-                <a:spcPts val="700"/>
+                <a:spcPts val="800"/>
               </a:spcAft>
               <a:defRPr sz="1900">
                 <a:solidFill>
-                  <a:srgbClr val="1E1E1E"/>
+                  <a:srgbClr val="232323"/>
                 </a:solidFill>
               </a:defRPr>
             </a:pPr>
             <a:r>
-              <a:t>Karol-Code als ausführbare Umsetzung</a:t>
+              <a:t>liefert ein erwartbares Ergebnis (in endlicher Zeit)</a:t>
             </a:r>
           </a:p>
         </p:txBody>
@@ -5187,18 +5211,18 @@
         </p:nvSpPr>
         <p:spPr>
           <a:xfrm>
-            <a:off x="6309360" y="1280160"/>
-            <a:ext cx="5029200" cy="530352"/>
+            <a:off x="6400800" y="1371600"/>
+            <a:ext cx="2011680" cy="731520"/>
           </a:xfrm>
           <a:prstGeom prst="roundRect">
             <a:avLst/>
           </a:prstGeom>
           <a:solidFill>
-            <a:srgbClr val="E5ECF6"/>
+            <a:srgbClr val="F2F6FA"/>
           </a:solidFill>
           <a:ln>
             <a:solidFill>
-              <a:srgbClr val="305396"/>
+              <a:srgbClr val="4472C4"/>
             </a:solidFill>
           </a:ln>
         </p:spPr>
@@ -5222,12 +5246,12 @@
           <a:p>
             <a:pPr algn="ctr"/>
             <a:r>
-              <a:rPr sz="1200" b="1">
-                <a:solidFill>
-                  <a:srgbClr val="202C3C"/>
+              <a:rPr sz="1400" b="1">
+                <a:solidFill>
+                  <a:srgbClr val="1F374E"/>
                 </a:solidFill>
               </a:rPr>
-              <a:t>Sequenz</a:t>
+              <a:t>eindeutig</a:t>
             </a:r>
           </a:p>
         </p:txBody>
@@ -5240,18 +5264,18 @@
         </p:nvSpPr>
         <p:spPr>
           <a:xfrm>
-            <a:off x="6629400" y="1892807"/>
-            <a:ext cx="4389120" cy="530352"/>
+            <a:off x="8686800" y="1371600"/>
+            <a:ext cx="2011680" cy="731520"/>
           </a:xfrm>
           <a:prstGeom prst="roundRect">
             <a:avLst/>
           </a:prstGeom>
           <a:solidFill>
-            <a:srgbClr val="FFE899"/>
+            <a:srgbClr val="DCE6F1"/>
           </a:solidFill>
           <a:ln>
             <a:solidFill>
-              <a:srgbClr val="305396"/>
+              <a:srgbClr val="4472C4"/>
             </a:solidFill>
           </a:ln>
         </p:spPr>
@@ -5275,12 +5299,12 @@
           <a:p>
             <a:pPr algn="ctr"/>
             <a:r>
-              <a:rPr sz="1200" b="1">
-                <a:solidFill>
-                  <a:srgbClr val="202C3C"/>
+              <a:rPr sz="1400" b="1">
+                <a:solidFill>
+                  <a:srgbClr val="1F374E"/>
                 </a:solidFill>
               </a:rPr>
-              <a:t>Anweisung 1</a:t>
+              <a:t>ausführbar</a:t>
             </a:r>
           </a:p>
         </p:txBody>
@@ -5293,18 +5317,18 @@
         </p:nvSpPr>
         <p:spPr>
           <a:xfrm>
-            <a:off x="6629400" y="2505456"/>
-            <a:ext cx="4389120" cy="530352"/>
+            <a:off x="6400800" y="2606040"/>
+            <a:ext cx="2011680" cy="731520"/>
           </a:xfrm>
           <a:prstGeom prst="roundRect">
             <a:avLst/>
           </a:prstGeom>
           <a:solidFill>
-            <a:srgbClr val="FFE899"/>
+            <a:srgbClr val="FFE699"/>
           </a:solidFill>
           <a:ln>
             <a:solidFill>
-              <a:srgbClr val="305396"/>
+              <a:srgbClr val="4472C4"/>
             </a:solidFill>
           </a:ln>
         </p:spPr>
@@ -5328,12 +5352,12 @@
           <a:p>
             <a:pPr algn="ctr"/>
             <a:r>
-              <a:rPr sz="1200" b="1">
-                <a:solidFill>
-                  <a:srgbClr val="202C3C"/>
+              <a:rPr sz="1400" b="1">
+                <a:solidFill>
+                  <a:srgbClr val="1F374E"/>
                 </a:solidFill>
               </a:rPr>
-              <a:t>Anweisung 2</a:t>
+              <a:t>endlich</a:t>
             </a:r>
           </a:p>
         </p:txBody>
@@ -5346,18 +5370,18 @@
         </p:nvSpPr>
         <p:spPr>
           <a:xfrm>
-            <a:off x="6309360" y="3118103"/>
-            <a:ext cx="5029200" cy="530352"/>
+            <a:off x="8686800" y="2606040"/>
+            <a:ext cx="2011680" cy="731520"/>
           </a:xfrm>
           <a:prstGeom prst="roundRect">
             <a:avLst/>
           </a:prstGeom>
           <a:solidFill>
-            <a:srgbClr val="E5ECF6"/>
+            <a:srgbClr val="E2EFDA"/>
           </a:solidFill>
           <a:ln>
             <a:solidFill>
-              <a:srgbClr val="305396"/>
+              <a:srgbClr val="4472C4"/>
             </a:solidFill>
           </a:ln>
         </p:spPr>
@@ -5381,79 +5405,27 @@
           <a:p>
             <a:pPr algn="ctr"/>
             <a:r>
-              <a:rPr sz="1200" b="1">
-                <a:solidFill>
-                  <a:srgbClr val="202C3C"/>
+              <a:rPr sz="1400" b="1">
+                <a:solidFill>
+                  <a:srgbClr val="1F374E"/>
                 </a:solidFill>
               </a:rPr>
-              <a:t>Entscheidung?</a:t>
-            </a:r>
-          </a:p>
-        </p:txBody>
-      </p:sp>
-      <p:sp>
-        <p:nvSpPr>
-          <p:cNvPr id="9" name="Rounded Rectangle 8"/>
-          <p:cNvSpPr/>
-          <p:nvPr/>
-        </p:nvSpPr>
-        <p:spPr>
-          <a:xfrm>
-            <a:off x="6629400" y="3730752"/>
-            <a:ext cx="4389120" cy="530352"/>
-          </a:xfrm>
-          <a:prstGeom prst="roundRect">
-            <a:avLst/>
-          </a:prstGeom>
-          <a:solidFill>
-            <a:srgbClr val="FFE899"/>
-          </a:solidFill>
-          <a:ln>
-            <a:solidFill>
-              <a:srgbClr val="305396"/>
-            </a:solidFill>
-          </a:ln>
-        </p:spPr>
-        <p:style>
-          <a:lnRef idx="1">
-            <a:schemeClr val="accent1"/>
-          </a:lnRef>
-          <a:fillRef idx="3">
-            <a:schemeClr val="accent1"/>
-          </a:fillRef>
-          <a:effectRef idx="2">
-            <a:schemeClr val="accent1"/>
-          </a:effectRef>
-          <a:fontRef idx="minor">
-            <a:schemeClr val="lt1"/>
-          </a:fontRef>
-        </p:style>
-        <p:txBody>
-          <a:bodyPr rtlCol="0" anchor="ctr" wrap="square"/>
-          <a:lstStyle/>
-          <a:p>
-            <a:pPr algn="ctr"/>
-            <a:r>
-              <a:rPr sz="1200" b="1">
-                <a:solidFill>
-                  <a:srgbClr val="202C3C"/>
-                </a:solidFill>
-              </a:rPr>
-              <a:t>Dann / Sonst</a:t>
-            </a:r>
-          </a:p>
-        </p:txBody>
-      </p:sp>
-      <p:sp>
-        <p:nvSpPr>
-          <p:cNvPr id="10" name="TextBox 9"/>
+              <a:t>erwartbares Ergebnis
+(in endlicher Zeit)</a:t>
+            </a:r>
+          </a:p>
+        </p:txBody>
+      </p:sp>
+      <p:sp>
+        <p:nvSpPr>
+          <p:cNvPr id="9" name="TextBox 8"/>
           <p:cNvSpPr txBox="1"/>
           <p:nvPr/>
         </p:nvSpPr>
         <p:spPr>
           <a:xfrm>
-            <a:off x="365760" y="6510528"/>
-            <a:ext cx="11430000" cy="228600"/>
+            <a:off x="502920" y="6510528"/>
+            <a:ext cx="11064240" cy="182880"/>
           </a:xfrm>
           <a:prstGeom prst="rect">
             <a:avLst/>
@@ -5470,7 +5442,7 @@
             <a:r>
               <a:rPr sz="800">
                 <a:solidFill>
-                  <a:srgbClr val="6E6E6E"/>
+                  <a:srgbClr val="646464"/>
                 </a:solidFill>
               </a:rPr>
               <a:t>Grafik: eigene Darstellung</a:t>
@@ -5505,13 +5477,13 @@
         <p:spPr>
           <a:xfrm>
             <a:off x="0" y="0"/>
-            <a:ext cx="12191695" cy="109728"/>
+            <a:ext cx="12191695" cy="100584"/>
           </a:xfrm>
           <a:prstGeom prst="rect">
             <a:avLst/>
           </a:prstGeom>
           <a:solidFill>
-            <a:srgbClr val="305396"/>
+            <a:srgbClr val="4472C4"/>
           </a:solidFill>
           <a:ln>
             <a:noFill/>
@@ -5548,7 +5520,7 @@
         <p:spPr>
           <a:xfrm>
             <a:off x="594360" y="320040"/>
-            <a:ext cx="10972800" cy="548640"/>
+            <a:ext cx="10972800" cy="502920"/>
           </a:xfrm>
           <a:prstGeom prst="rect">
             <a:avLst/>
@@ -5564,10 +5536,10 @@
             <a:r>
               <a:rPr sz="2600" b="1">
                 <a:solidFill>
-                  <a:srgbClr val="202C3C"/>
+                  <a:srgbClr val="1F374E"/>
                 </a:solidFill>
               </a:rPr>
-              <a:t>Bedingungen mit Beispielen</a:t>
+              <a:t>Abläufe darstellen</a:t>
             </a:r>
           </a:p>
         </p:txBody>
@@ -5581,7 +5553,7 @@
         <p:spPr>
           <a:xfrm>
             <a:off x="685800" y="1234440"/>
-            <a:ext cx="5394960" cy="5029200"/>
+            <a:ext cx="5303520" cy="4937760"/>
           </a:xfrm>
           <a:prstGeom prst="rect">
             <a:avLst/>
@@ -5596,85 +5568,70 @@
           <a:p>
             <a:pPr>
               <a:spcAft>
-                <a:spcPts val="700"/>
+                <a:spcPts val="800"/>
               </a:spcAft>
               <a:defRPr sz="1900">
                 <a:solidFill>
-                  <a:srgbClr val="1E1E1E"/>
+                  <a:srgbClr val="232323"/>
                 </a:solidFill>
               </a:defRPr>
             </a:pPr>
             <a:r>
-              <a:t>Bedingung beantwortet WAHR oder FALSCH.</a:t>
+              <a:t>Schritte können nummeriert werden.</a:t>
             </a:r>
           </a:p>
           <a:p>
             <a:pPr>
               <a:spcAft>
-                <a:spcPts val="700"/>
+                <a:spcPts val="800"/>
               </a:spcAft>
               <a:defRPr sz="1900">
                 <a:solidFill>
-                  <a:srgbClr val="1E1E1E"/>
+                  <a:srgbClr val="232323"/>
                 </a:solidFill>
               </a:defRPr>
             </a:pPr>
             <a:r>
-              <a:t>Wenn Passwort korrekt, dann Zugriff erlauben.</a:t>
+              <a:t>Pseudocode beschreibt Abläufe textuell.</a:t>
             </a:r>
           </a:p>
           <a:p>
             <a:pPr>
               <a:spcAft>
-                <a:spcPts val="700"/>
+                <a:spcPts val="800"/>
               </a:spcAft>
               <a:defRPr sz="1900">
                 <a:solidFill>
-                  <a:srgbClr val="1E1E1E"/>
+                  <a:srgbClr val="232323"/>
                 </a:solidFill>
               </a:defRPr>
             </a:pPr>
             <a:r>
-              <a:t>Wenn Wand vor Karol, dann drehen, sonst Schritt.</a:t>
-            </a:r>
-          </a:p>
-          <a:p>
-            <a:pPr>
-              <a:spcAft>
-                <a:spcPts val="700"/>
-              </a:spcAft>
-              <a:defRPr sz="1900">
-                <a:solidFill>
-                  <a:srgbClr val="1E1E1E"/>
-                </a:solidFill>
-              </a:defRPr>
-            </a:pPr>
-            <a:r>
-              <a:t>Bedingungen steuern den Ablauf.</a:t>
-            </a:r>
-          </a:p>
-        </p:txBody>
-      </p:sp>
-      <p:sp>
-        <p:nvSpPr>
-          <p:cNvPr id="5" name="Rectangle 4"/>
+              <a:t>Struktogramme stellen Abläufe grafisch dar.</a:t>
+            </a:r>
+          </a:p>
+        </p:txBody>
+      </p:sp>
+      <p:sp>
+        <p:nvSpPr>
+          <p:cNvPr id="5" name="Rounded Rectangle 4"/>
           <p:cNvSpPr/>
           <p:nvPr/>
         </p:nvSpPr>
         <p:spPr>
           <a:xfrm>
-            <a:off x="6400800" y="1417320"/>
-            <a:ext cx="4754880" cy="2926080"/>
-          </a:xfrm>
-          <a:prstGeom prst="rect">
+            <a:off x="6217920" y="1188720"/>
+            <a:ext cx="5029200" cy="566928"/>
+          </a:xfrm>
+          <a:prstGeom prst="roundRect">
             <a:avLst/>
           </a:prstGeom>
           <a:solidFill>
-            <a:srgbClr val="FCFCFC"/>
+            <a:srgbClr val="DCE6F1"/>
           </a:solidFill>
           <a:ln>
             <a:solidFill>
-              <a:srgbClr val="6E6E6E"/>
+              <a:srgbClr val="4472C4"/>
             </a:solidFill>
           </a:ln>
         </p:spPr>
@@ -5693,36 +5650,137 @@
           </a:fontRef>
         </p:style>
         <p:txBody>
-          <a:bodyPr rtlCol="0" anchor="ctr" wrap="none"/>
+          <a:bodyPr rtlCol="0" anchor="ctr" wrap="square"/>
           <a:lstStyle/>
           <a:p>
             <a:pPr algn="ctr"/>
             <a:r>
-              <a:rPr sz="1600">
-                <a:solidFill>
-                  <a:srgbClr val="1E1E1E"/>
-                </a:solidFill>
-                <a:latin typeface="Consolas"/>
+              <a:rPr sz="1300" b="1">
+                <a:solidFill>
+                  <a:srgbClr val="1F374E"/>
+                </a:solidFill>
               </a:rPr>
-              <a:t>wenn IstWand dann
-    LinksDrehen
-sonst
-    Schritt
-*wenn</a:t>
-            </a:r>
-          </a:p>
-        </p:txBody>
-      </p:sp>
-      <p:sp>
-        <p:nvSpPr>
-          <p:cNvPr id="6" name="TextBox 5"/>
+              <a:t>Sequenz</a:t>
+            </a:r>
+          </a:p>
+        </p:txBody>
+      </p:sp>
+      <p:sp>
+        <p:nvSpPr>
+          <p:cNvPr id="6" name="Rounded Rectangle 5"/>
+          <p:cNvSpPr/>
+          <p:nvPr/>
+        </p:nvSpPr>
+        <p:spPr>
+          <a:xfrm>
+            <a:off x="6537959" y="1828800"/>
+            <a:ext cx="4389120" cy="566928"/>
+          </a:xfrm>
+          <a:prstGeom prst="roundRect">
+            <a:avLst/>
+          </a:prstGeom>
+          <a:solidFill>
+            <a:srgbClr val="F2F6FA"/>
+          </a:solidFill>
+          <a:ln>
+            <a:solidFill>
+              <a:srgbClr val="4472C4"/>
+            </a:solidFill>
+          </a:ln>
+        </p:spPr>
+        <p:style>
+          <a:lnRef idx="1">
+            <a:schemeClr val="accent1"/>
+          </a:lnRef>
+          <a:fillRef idx="3">
+            <a:schemeClr val="accent1"/>
+          </a:fillRef>
+          <a:effectRef idx="2">
+            <a:schemeClr val="accent1"/>
+          </a:effectRef>
+          <a:fontRef idx="minor">
+            <a:schemeClr val="lt1"/>
+          </a:fontRef>
+        </p:style>
+        <p:txBody>
+          <a:bodyPr rtlCol="0" anchor="ctr" wrap="square"/>
+          <a:lstStyle/>
+          <a:p>
+            <a:pPr algn="ctr"/>
+            <a:r>
+              <a:rPr sz="1300" b="1">
+                <a:solidFill>
+                  <a:srgbClr val="1F374E"/>
+                </a:solidFill>
+              </a:rPr>
+              <a:t>Schritt 1</a:t>
+            </a:r>
+          </a:p>
+        </p:txBody>
+      </p:sp>
+      <p:sp>
+        <p:nvSpPr>
+          <p:cNvPr id="7" name="Rounded Rectangle 6"/>
+          <p:cNvSpPr/>
+          <p:nvPr/>
+        </p:nvSpPr>
+        <p:spPr>
+          <a:xfrm>
+            <a:off x="6537959" y="2468880"/>
+            <a:ext cx="4389120" cy="566928"/>
+          </a:xfrm>
+          <a:prstGeom prst="roundRect">
+            <a:avLst/>
+          </a:prstGeom>
+          <a:solidFill>
+            <a:srgbClr val="F2F6FA"/>
+          </a:solidFill>
+          <a:ln>
+            <a:solidFill>
+              <a:srgbClr val="4472C4"/>
+            </a:solidFill>
+          </a:ln>
+        </p:spPr>
+        <p:style>
+          <a:lnRef idx="1">
+            <a:schemeClr val="accent1"/>
+          </a:lnRef>
+          <a:fillRef idx="3">
+            <a:schemeClr val="accent1"/>
+          </a:fillRef>
+          <a:effectRef idx="2">
+            <a:schemeClr val="accent1"/>
+          </a:effectRef>
+          <a:fontRef idx="minor">
+            <a:schemeClr val="lt1"/>
+          </a:fontRef>
+        </p:style>
+        <p:txBody>
+          <a:bodyPr rtlCol="0" anchor="ctr" wrap="square"/>
+          <a:lstStyle/>
+          <a:p>
+            <a:pPr algn="ctr"/>
+            <a:r>
+              <a:rPr sz="1300" b="1">
+                <a:solidFill>
+                  <a:srgbClr val="1F374E"/>
+                </a:solidFill>
+              </a:rPr>
+              <a:t>Schritt 2</a:t>
+            </a:r>
+          </a:p>
+        </p:txBody>
+      </p:sp>
+      <p:sp>
+        <p:nvSpPr>
+          <p:cNvPr id="8" name="TextBox 7"/>
           <p:cNvSpPr txBox="1"/>
           <p:nvPr/>
         </p:nvSpPr>
         <p:spPr>
           <a:xfrm>
-            <a:off x="365760" y="6510528"/>
-            <a:ext cx="11430000" cy="228600"/>
+            <a:off x="502920" y="6510528"/>
+            <a:ext cx="11064240" cy="182880"/>
           </a:xfrm>
           <a:prstGeom prst="rect">
             <a:avLst/>
@@ -5739,7 +5797,7 @@
             <a:r>
               <a:rPr sz="800">
                 <a:solidFill>
-                  <a:srgbClr val="6E6E6E"/>
+                  <a:srgbClr val="646464"/>
                 </a:solidFill>
               </a:rPr>
               <a:t>Grafik: eigene Darstellung</a:t>
@@ -5774,13 +5832,13 @@
         <p:spPr>
           <a:xfrm>
             <a:off x="0" y="0"/>
-            <a:ext cx="12191695" cy="109728"/>
+            <a:ext cx="12191695" cy="100584"/>
           </a:xfrm>
           <a:prstGeom prst="rect">
             <a:avLst/>
           </a:prstGeom>
           <a:solidFill>
-            <a:srgbClr val="305396"/>
+            <a:srgbClr val="4472C4"/>
           </a:solidFill>
           <a:ln>
             <a:noFill/>
@@ -5817,7 +5875,7 @@
         <p:spPr>
           <a:xfrm>
             <a:off x="594360" y="320040"/>
-            <a:ext cx="10972800" cy="548640"/>
+            <a:ext cx="10972800" cy="502920"/>
           </a:xfrm>
           <a:prstGeom prst="rect">
             <a:avLst/>
@@ -5833,10 +5891,10 @@
             <a:r>
               <a:rPr sz="2600" b="1">
                 <a:solidFill>
-                  <a:srgbClr val="202C3C"/>
+                  <a:srgbClr val="1F374E"/>
                 </a:solidFill>
               </a:rPr>
-              <a:t>Feste und bedingte Wiederholung</a:t>
+              <a:t>Bedingungen</a:t>
             </a:r>
           </a:p>
         </p:txBody>
@@ -5850,7 +5908,7 @@
         <p:spPr>
           <a:xfrm>
             <a:off x="685800" y="1234440"/>
-            <a:ext cx="5394960" cy="5029200"/>
+            <a:ext cx="5303520" cy="4937760"/>
           </a:xfrm>
           <a:prstGeom prst="rect">
             <a:avLst/>
@@ -5865,85 +5923,70 @@
           <a:p>
             <a:pPr>
               <a:spcAft>
-                <a:spcPts val="700"/>
+                <a:spcPts val="800"/>
               </a:spcAft>
               <a:defRPr sz="1900">
                 <a:solidFill>
-                  <a:srgbClr val="1E1E1E"/>
+                  <a:srgbClr val="232323"/>
                 </a:solidFill>
               </a:defRPr>
             </a:pPr>
             <a:r>
-              <a:t>Fest: Anzahl vorher bekannt.</a:t>
+              <a:t>Eine Bedingung ist eine Aussage, die WAHR oder FALSCH ist.</a:t>
             </a:r>
           </a:p>
           <a:p>
             <a:pPr>
               <a:spcAft>
-                <a:spcPts val="700"/>
+                <a:spcPts val="800"/>
               </a:spcAft>
               <a:defRPr sz="1900">
                 <a:solidFill>
-                  <a:srgbClr val="1E1E1E"/>
+                  <a:srgbClr val="232323"/>
                 </a:solidFill>
               </a:defRPr>
             </a:pPr>
             <a:r>
-              <a:t>Bedingt: Fortsetzung hängt von Bedingung ab.</a:t>
+              <a:t>WENN Passwort korrekt, DANN Zugriff erlauben, SONST Fehlermeldung.</a:t>
             </a:r>
           </a:p>
           <a:p>
             <a:pPr>
               <a:spcAft>
-                <a:spcPts val="700"/>
+                <a:spcPts val="800"/>
               </a:spcAft>
               <a:defRPr sz="1900">
                 <a:solidFill>
-                  <a:srgbClr val="1E1E1E"/>
+                  <a:srgbClr val="232323"/>
                 </a:solidFill>
               </a:defRPr>
             </a:pPr>
             <a:r>
-              <a:t>Fest = Wie oft?</a:t>
-            </a:r>
-          </a:p>
-          <a:p>
-            <a:pPr>
-              <a:spcAft>
-                <a:spcPts val="700"/>
-              </a:spcAft>
-              <a:defRPr sz="1900">
-                <a:solidFill>
-                  <a:srgbClr val="1E1E1E"/>
-                </a:solidFill>
-              </a:defRPr>
-            </a:pPr>
-            <a:r>
-              <a:t>Bedingt = Wie lange?</a:t>
-            </a:r>
-          </a:p>
-        </p:txBody>
-      </p:sp>
-      <p:sp>
-        <p:nvSpPr>
-          <p:cNvPr id="5" name="Rectangle 4"/>
+              <a:t>Robot Karol: WENN vor Karol eine Wand ist, DANN drehen, SONST Schritt.</a:t>
+            </a:r>
+          </a:p>
+        </p:txBody>
+      </p:sp>
+      <p:sp>
+        <p:nvSpPr>
+          <p:cNvPr id="5" name="Diamond 4"/>
           <p:cNvSpPr/>
           <p:nvPr/>
         </p:nvSpPr>
         <p:spPr>
           <a:xfrm>
-            <a:off x="6217920" y="1188720"/>
-            <a:ext cx="5120640" cy="4206240"/>
-          </a:xfrm>
-          <a:prstGeom prst="rect">
+            <a:off x="7680960" y="1280160"/>
+            <a:ext cx="2011680" cy="1280160"/>
+          </a:xfrm>
+          <a:prstGeom prst="diamond">
             <a:avLst/>
           </a:prstGeom>
           <a:solidFill>
-            <a:srgbClr val="FCFCFC"/>
+            <a:srgbClr val="FFE699"/>
           </a:solidFill>
           <a:ln>
             <a:solidFill>
-              <a:srgbClr val="6E6E6E"/>
+              <a:srgbClr val="4472C4"/>
             </a:solidFill>
           </a:ln>
         </p:spPr>
@@ -5962,39 +6005,137 @@
           </a:fontRef>
         </p:style>
         <p:txBody>
-          <a:bodyPr rtlCol="0" anchor="ctr" wrap="none"/>
+          <a:bodyPr rtlCol="0" anchor="ctr"/>
           <a:lstStyle/>
           <a:p>
             <a:pPr algn="ctr"/>
             <a:r>
-              <a:rPr sz="1400">
-                <a:solidFill>
-                  <a:srgbClr val="1E1E1E"/>
-                </a:solidFill>
-                <a:latin typeface="Consolas"/>
+              <a:t>Bedingung?</a:t>
+            </a:r>
+          </a:p>
+          <a:p>
+            <a:r>
+              <a:t>WAHR / FALSCH</a:t>
+            </a:r>
+          </a:p>
+        </p:txBody>
+      </p:sp>
+      <p:sp>
+        <p:nvSpPr>
+          <p:cNvPr id="6" name="Rounded Rectangle 5"/>
+          <p:cNvSpPr/>
+          <p:nvPr/>
+        </p:nvSpPr>
+        <p:spPr>
+          <a:xfrm>
+            <a:off x="6309360" y="3154680"/>
+            <a:ext cx="1920240" cy="640080"/>
+          </a:xfrm>
+          <a:prstGeom prst="roundRect">
+            <a:avLst/>
+          </a:prstGeom>
+          <a:solidFill>
+            <a:srgbClr val="E2EFDA"/>
+          </a:solidFill>
+          <a:ln>
+            <a:solidFill>
+              <a:srgbClr val="4472C4"/>
+            </a:solidFill>
+          </a:ln>
+        </p:spPr>
+        <p:style>
+          <a:lnRef idx="1">
+            <a:schemeClr val="accent1"/>
+          </a:lnRef>
+          <a:fillRef idx="3">
+            <a:schemeClr val="accent1"/>
+          </a:fillRef>
+          <a:effectRef idx="2">
+            <a:schemeClr val="accent1"/>
+          </a:effectRef>
+          <a:fontRef idx="minor">
+            <a:schemeClr val="lt1"/>
+          </a:fontRef>
+        </p:style>
+        <p:txBody>
+          <a:bodyPr rtlCol="0" anchor="ctr" wrap="square"/>
+          <a:lstStyle/>
+          <a:p>
+            <a:pPr algn="ctr"/>
+            <a:r>
+              <a:rPr sz="1500" b="1">
+                <a:solidFill>
+                  <a:srgbClr val="1F374E"/>
+                </a:solidFill>
               </a:rPr>
-              <a:t>FEST:
-wiederhole 5 mal
-    Schritt
-*wiederhole
-BEDINGT:
-solange NichtIstWand
-    Schritt
-*solange</a:t>
-            </a:r>
-          </a:p>
-        </p:txBody>
-      </p:sp>
-      <p:sp>
-        <p:nvSpPr>
-          <p:cNvPr id="6" name="TextBox 5"/>
+              <a:t>DANN</a:t>
+            </a:r>
+          </a:p>
+        </p:txBody>
+      </p:sp>
+      <p:sp>
+        <p:nvSpPr>
+          <p:cNvPr id="7" name="Rounded Rectangle 6"/>
+          <p:cNvSpPr/>
+          <p:nvPr/>
+        </p:nvSpPr>
+        <p:spPr>
+          <a:xfrm>
+            <a:off x="9418320" y="3154680"/>
+            <a:ext cx="1920240" cy="640080"/>
+          </a:xfrm>
+          <a:prstGeom prst="roundRect">
+            <a:avLst/>
+          </a:prstGeom>
+          <a:solidFill>
+            <a:srgbClr val="F8CBAD"/>
+          </a:solidFill>
+          <a:ln>
+            <a:solidFill>
+              <a:srgbClr val="4472C4"/>
+            </a:solidFill>
+          </a:ln>
+        </p:spPr>
+        <p:style>
+          <a:lnRef idx="1">
+            <a:schemeClr val="accent1"/>
+          </a:lnRef>
+          <a:fillRef idx="3">
+            <a:schemeClr val="accent1"/>
+          </a:fillRef>
+          <a:effectRef idx="2">
+            <a:schemeClr val="accent1"/>
+          </a:effectRef>
+          <a:fontRef idx="minor">
+            <a:schemeClr val="lt1"/>
+          </a:fontRef>
+        </p:style>
+        <p:txBody>
+          <a:bodyPr rtlCol="0" anchor="ctr" wrap="square"/>
+          <a:lstStyle/>
+          <a:p>
+            <a:pPr algn="ctr"/>
+            <a:r>
+              <a:rPr sz="1500" b="1">
+                <a:solidFill>
+                  <a:srgbClr val="1F374E"/>
+                </a:solidFill>
+              </a:rPr>
+              <a:t>SONST</a:t>
+            </a:r>
+          </a:p>
+        </p:txBody>
+      </p:sp>
+      <p:sp>
+        <p:nvSpPr>
+          <p:cNvPr id="8" name="TextBox 7"/>
           <p:cNvSpPr txBox="1"/>
           <p:nvPr/>
         </p:nvSpPr>
         <p:spPr>
           <a:xfrm>
-            <a:off x="365760" y="6510528"/>
-            <a:ext cx="11430000" cy="228600"/>
+            <a:off x="502920" y="6510528"/>
+            <a:ext cx="11064240" cy="182880"/>
           </a:xfrm>
           <a:prstGeom prst="rect">
             <a:avLst/>
@@ -6011,7 +6152,7 @@
             <a:r>
               <a:rPr sz="800">
                 <a:solidFill>
-                  <a:srgbClr val="6E6E6E"/>
+                  <a:srgbClr val="646464"/>
                 </a:solidFill>
               </a:rPr>
               <a:t>Grafik: eigene Darstellung</a:t>
@@ -6046,13 +6187,13 @@
         <p:spPr>
           <a:xfrm>
             <a:off x="0" y="0"/>
-            <a:ext cx="12191695" cy="109728"/>
+            <a:ext cx="12191695" cy="100584"/>
           </a:xfrm>
           <a:prstGeom prst="rect">
             <a:avLst/>
           </a:prstGeom>
           <a:solidFill>
-            <a:srgbClr val="305396"/>
+            <a:srgbClr val="4472C4"/>
           </a:solidFill>
           <a:ln>
             <a:noFill/>
@@ -6089,7 +6230,7 @@
         <p:spPr>
           <a:xfrm>
             <a:off x="594360" y="320040"/>
-            <a:ext cx="10972800" cy="548640"/>
+            <a:ext cx="10972800" cy="502920"/>
           </a:xfrm>
           <a:prstGeom prst="rect">
             <a:avLst/>
@@ -6105,10 +6246,10 @@
             <a:r>
               <a:rPr sz="2600" b="1">
                 <a:solidFill>
-                  <a:srgbClr val="202C3C"/>
+                  <a:srgbClr val="1F374E"/>
                 </a:solidFill>
               </a:rPr>
-              <a:t>Verschachtelung</a:t>
+              <a:t>Wiederholungen</a:t>
             </a:r>
           </a:p>
         </p:txBody>
@@ -6122,7 +6263,7 @@
         <p:spPr>
           <a:xfrm>
             <a:off x="685800" y="1234440"/>
-            <a:ext cx="5394960" cy="5029200"/>
+            <a:ext cx="5303520" cy="4937760"/>
           </a:xfrm>
           <a:prstGeom prst="rect">
             <a:avLst/>
@@ -6137,85 +6278,70 @@
           <a:p>
             <a:pPr>
               <a:spcAft>
-                <a:spcPts val="700"/>
+                <a:spcPts val="800"/>
               </a:spcAft>
               <a:defRPr sz="1900">
                 <a:solidFill>
-                  <a:srgbClr val="1E1E1E"/>
+                  <a:srgbClr val="232323"/>
                 </a:solidFill>
               </a:defRPr>
             </a:pPr>
             <a:r>
-              <a:t>Kontrollstrukturen können ineinander liegen.</a:t>
+              <a:t>Feste Wiederholung: Anzahl vorher bekannt.</a:t>
             </a:r>
           </a:p>
           <a:p>
             <a:pPr>
               <a:spcAft>
-                <a:spcPts val="700"/>
+                <a:spcPts val="800"/>
               </a:spcAft>
               <a:defRPr sz="1900">
                 <a:solidFill>
-                  <a:srgbClr val="1E1E1E"/>
+                  <a:srgbClr val="232323"/>
                 </a:solidFill>
               </a:defRPr>
             </a:pPr>
             <a:r>
-              <a:t>Beispiel: Schleife in Schleife.</a:t>
+              <a:t>Bedingte Wiederholung: eine Bedingung entscheidet über die Fortsetzung.</a:t>
             </a:r>
           </a:p>
           <a:p>
             <a:pPr>
               <a:spcAft>
-                <a:spcPts val="700"/>
+                <a:spcPts val="800"/>
               </a:spcAft>
               <a:defRPr sz="1900">
                 <a:solidFill>
-                  <a:srgbClr val="1E1E1E"/>
+                  <a:srgbClr val="232323"/>
                 </a:solidFill>
               </a:defRPr>
             </a:pPr>
             <a:r>
-              <a:t>Auch Bedingungen in Schleifen sind möglich.</a:t>
-            </a:r>
-          </a:p>
-          <a:p>
-            <a:pPr>
-              <a:spcAft>
-                <a:spcPts val="700"/>
-              </a:spcAft>
-              <a:defRPr sz="1900">
-                <a:solidFill>
-                  <a:srgbClr val="1E1E1E"/>
-                </a:solidFill>
-              </a:defRPr>
-            </a:pPr>
-            <a:r>
-              <a:t>Einrückung zeigt die Struktur.</a:t>
-            </a:r>
-          </a:p>
-        </p:txBody>
-      </p:sp>
-      <p:sp>
-        <p:nvSpPr>
-          <p:cNvPr id="5" name="Rounded Rectangle 4"/>
+              <a:t>Beide Formen vermeiden unnötig wiederholten Code.</a:t>
+            </a:r>
+          </a:p>
+        </p:txBody>
+      </p:sp>
+      <p:sp>
+        <p:nvSpPr>
+          <p:cNvPr id="5" name="Rectangle 4"/>
           <p:cNvSpPr/>
           <p:nvPr/>
         </p:nvSpPr>
         <p:spPr>
           <a:xfrm>
             <a:off x="6309360" y="1280160"/>
-            <a:ext cx="5029200" cy="530352"/>
-          </a:xfrm>
-          <a:prstGeom prst="roundRect">
+            <a:ext cx="4937760" cy="4023360"/>
+          </a:xfrm>
+          <a:prstGeom prst="rect">
             <a:avLst/>
           </a:prstGeom>
           <a:solidFill>
-            <a:srgbClr val="E5ECF6"/>
+            <a:srgbClr val="FAFAFA"/>
           </a:solidFill>
           <a:ln>
             <a:solidFill>
-              <a:srgbClr val="305396"/>
+              <a:srgbClr val="646464"/>
             </a:solidFill>
           </a:ln>
         </p:spPr>
@@ -6234,243 +6360,39 @@
           </a:fontRef>
         </p:style>
         <p:txBody>
-          <a:bodyPr rtlCol="0" anchor="ctr" wrap="square"/>
+          <a:bodyPr rtlCol="0" anchor="ctr" wrap="none"/>
           <a:lstStyle/>
           <a:p>
             <a:pPr algn="ctr"/>
             <a:r>
-              <a:rPr sz="1200" b="1">
-                <a:solidFill>
-                  <a:srgbClr val="202C3C"/>
-                </a:solidFill>
+              <a:rPr sz="1400">
+                <a:solidFill>
+                  <a:srgbClr val="232323"/>
+                </a:solidFill>
+                <a:latin typeface="Consolas"/>
               </a:rPr>
-              <a:t>4-mal: Reihen</a:t>
-            </a:r>
-          </a:p>
-        </p:txBody>
-      </p:sp>
-      <p:sp>
-        <p:nvSpPr>
-          <p:cNvPr id="6" name="Rounded Rectangle 5"/>
-          <p:cNvSpPr/>
-          <p:nvPr/>
-        </p:nvSpPr>
-        <p:spPr>
-          <a:xfrm>
-            <a:off x="6629400" y="1892807"/>
-            <a:ext cx="4389120" cy="530352"/>
-          </a:xfrm>
-          <a:prstGeom prst="roundRect">
-            <a:avLst/>
-          </a:prstGeom>
-          <a:solidFill>
-            <a:srgbClr val="FFE899"/>
-          </a:solidFill>
-          <a:ln>
-            <a:solidFill>
-              <a:srgbClr val="305396"/>
-            </a:solidFill>
-          </a:ln>
-        </p:spPr>
-        <p:style>
-          <a:lnRef idx="1">
-            <a:schemeClr val="accent1"/>
-          </a:lnRef>
-          <a:fillRef idx="3">
-            <a:schemeClr val="accent1"/>
-          </a:fillRef>
-          <a:effectRef idx="2">
-            <a:schemeClr val="accent1"/>
-          </a:effectRef>
-          <a:fontRef idx="minor">
-            <a:schemeClr val="lt1"/>
-          </a:fontRef>
-        </p:style>
-        <p:txBody>
-          <a:bodyPr rtlCol="0" anchor="ctr" wrap="square"/>
-          <a:lstStyle/>
-          <a:p>
-            <a:pPr algn="ctr"/>
-            <a:r>
-              <a:rPr sz="1200" b="1">
-                <a:solidFill>
-                  <a:srgbClr val="202C3C"/>
-                </a:solidFill>
-              </a:rPr>
-              <a:t>4-mal: Felder</a:t>
-            </a:r>
-          </a:p>
-        </p:txBody>
-      </p:sp>
-      <p:sp>
-        <p:nvSpPr>
-          <p:cNvPr id="7" name="Rounded Rectangle 6"/>
-          <p:cNvSpPr/>
-          <p:nvPr/>
-        </p:nvSpPr>
-        <p:spPr>
-          <a:xfrm>
-            <a:off x="6949440" y="2505456"/>
-            <a:ext cx="3749039" cy="530352"/>
-          </a:xfrm>
-          <a:prstGeom prst="roundRect">
-            <a:avLst/>
-          </a:prstGeom>
-          <a:solidFill>
-            <a:srgbClr val="DDEEDD"/>
-          </a:solidFill>
-          <a:ln>
-            <a:solidFill>
-              <a:srgbClr val="305396"/>
-            </a:solidFill>
-          </a:ln>
-        </p:spPr>
-        <p:style>
-          <a:lnRef idx="1">
-            <a:schemeClr val="accent1"/>
-          </a:lnRef>
-          <a:fillRef idx="3">
-            <a:schemeClr val="accent1"/>
-          </a:fillRef>
-          <a:effectRef idx="2">
-            <a:schemeClr val="accent1"/>
-          </a:effectRef>
-          <a:fontRef idx="minor">
-            <a:schemeClr val="lt1"/>
-          </a:fontRef>
-        </p:style>
-        <p:txBody>
-          <a:bodyPr rtlCol="0" anchor="ctr" wrap="square"/>
-          <a:lstStyle/>
-          <a:p>
-            <a:pPr algn="ctr"/>
-            <a:r>
-              <a:rPr sz="1200" b="1">
-                <a:solidFill>
-                  <a:srgbClr val="202C3C"/>
-                </a:solidFill>
-              </a:rPr>
-              <a:t>Ziegel hinlegen</a:t>
-            </a:r>
-          </a:p>
-        </p:txBody>
-      </p:sp>
-      <p:sp>
-        <p:nvSpPr>
-          <p:cNvPr id="8" name="Rounded Rectangle 7"/>
-          <p:cNvSpPr/>
-          <p:nvPr/>
-        </p:nvSpPr>
-        <p:spPr>
-          <a:xfrm>
-            <a:off x="6949440" y="3118103"/>
-            <a:ext cx="3749039" cy="530352"/>
-          </a:xfrm>
-          <a:prstGeom prst="roundRect">
-            <a:avLst/>
-          </a:prstGeom>
-          <a:solidFill>
-            <a:srgbClr val="DDEEDD"/>
-          </a:solidFill>
-          <a:ln>
-            <a:solidFill>
-              <a:srgbClr val="305396"/>
-            </a:solidFill>
-          </a:ln>
-        </p:spPr>
-        <p:style>
-          <a:lnRef idx="1">
-            <a:schemeClr val="accent1"/>
-          </a:lnRef>
-          <a:fillRef idx="3">
-            <a:schemeClr val="accent1"/>
-          </a:fillRef>
-          <a:effectRef idx="2">
-            <a:schemeClr val="accent1"/>
-          </a:effectRef>
-          <a:fontRef idx="minor">
-            <a:schemeClr val="lt1"/>
-          </a:fontRef>
-        </p:style>
-        <p:txBody>
-          <a:bodyPr rtlCol="0" anchor="ctr" wrap="square"/>
-          <a:lstStyle/>
-          <a:p>
-            <a:pPr algn="ctr"/>
-            <a:r>
-              <a:rPr sz="1200" b="1">
-                <a:solidFill>
-                  <a:srgbClr val="202C3C"/>
-                </a:solidFill>
-              </a:rPr>
-              <a:t>Schritt</a:t>
-            </a:r>
-          </a:p>
-        </p:txBody>
-      </p:sp>
-      <p:sp>
-        <p:nvSpPr>
-          <p:cNvPr id="9" name="Rounded Rectangle 8"/>
-          <p:cNvSpPr/>
-          <p:nvPr/>
-        </p:nvSpPr>
-        <p:spPr>
-          <a:xfrm>
-            <a:off x="6629400" y="3730752"/>
-            <a:ext cx="4389120" cy="530352"/>
-          </a:xfrm>
-          <a:prstGeom prst="roundRect">
-            <a:avLst/>
-          </a:prstGeom>
-          <a:solidFill>
-            <a:srgbClr val="FFE899"/>
-          </a:solidFill>
-          <a:ln>
-            <a:solidFill>
-              <a:srgbClr val="305396"/>
-            </a:solidFill>
-          </a:ln>
-        </p:spPr>
-        <p:style>
-          <a:lnRef idx="1">
-            <a:schemeClr val="accent1"/>
-          </a:lnRef>
-          <a:fillRef idx="3">
-            <a:schemeClr val="accent1"/>
-          </a:fillRef>
-          <a:effectRef idx="2">
-            <a:schemeClr val="accent1"/>
-          </a:effectRef>
-          <a:fontRef idx="minor">
-            <a:schemeClr val="lt1"/>
-          </a:fontRef>
-        </p:style>
-        <p:txBody>
-          <a:bodyPr rtlCol="0" anchor="ctr" wrap="square"/>
-          <a:lstStyle/>
-          <a:p>
-            <a:pPr algn="ctr"/>
-            <a:r>
-              <a:rPr sz="1200" b="1">
-                <a:solidFill>
-                  <a:srgbClr val="202C3C"/>
-                </a:solidFill>
-              </a:rPr>
-              <a:t>Reihenwechsel</a:t>
-            </a:r>
-          </a:p>
-        </p:txBody>
-      </p:sp>
-      <p:sp>
-        <p:nvSpPr>
-          <p:cNvPr id="10" name="TextBox 9"/>
+              <a:t>FEST:
+wiederhole 5 mal
+    Schritt
+*wiederhole
+BEDINGT:
+solange NichtIstWand
+    Schritt
+*solange</a:t>
+            </a:r>
+          </a:p>
+        </p:txBody>
+      </p:sp>
+      <p:sp>
+        <p:nvSpPr>
+          <p:cNvPr id="6" name="TextBox 5"/>
           <p:cNvSpPr txBox="1"/>
           <p:nvPr/>
         </p:nvSpPr>
         <p:spPr>
           <a:xfrm>
-            <a:off x="365760" y="6510528"/>
-            <a:ext cx="11430000" cy="228600"/>
+            <a:off x="502920" y="6510528"/>
+            <a:ext cx="11064240" cy="182880"/>
           </a:xfrm>
           <a:prstGeom prst="rect">
             <a:avLst/>
@@ -6487,7 +6409,7 @@
             <a:r>
               <a:rPr sz="800">
                 <a:solidFill>
-                  <a:srgbClr val="6E6E6E"/>
+                  <a:srgbClr val="646464"/>
                 </a:solidFill>
               </a:rPr>
               <a:t>Grafik: eigene Darstellung</a:t>
@@ -6522,13 +6444,13 @@
         <p:spPr>
           <a:xfrm>
             <a:off x="0" y="0"/>
-            <a:ext cx="12191695" cy="109728"/>
+            <a:ext cx="12191695" cy="100584"/>
           </a:xfrm>
           <a:prstGeom prst="rect">
             <a:avLst/>
           </a:prstGeom>
           <a:solidFill>
-            <a:srgbClr val="305396"/>
+            <a:srgbClr val="4472C4"/>
           </a:solidFill>
           <a:ln>
             <a:noFill/>
@@ -6565,7 +6487,7 @@
         <p:spPr>
           <a:xfrm>
             <a:off x="594360" y="320040"/>
-            <a:ext cx="10972800" cy="548640"/>
+            <a:ext cx="10972800" cy="502920"/>
           </a:xfrm>
           <a:prstGeom prst="rect">
             <a:avLst/>
@@ -6581,10 +6503,10 @@
             <a:r>
               <a:rPr sz="2600" b="1">
                 <a:solidFill>
-                  <a:srgbClr val="202C3C"/>
+                  <a:srgbClr val="1F374E"/>
                 </a:solidFill>
               </a:rPr>
-              <a:t>Testfälle formulieren</a:t>
+              <a:t>Verschachtelung</a:t>
             </a:r>
           </a:p>
         </p:txBody>
@@ -6598,7 +6520,7 @@
         <p:spPr>
           <a:xfrm>
             <a:off x="685800" y="1234440"/>
-            <a:ext cx="5394960" cy="5029200"/>
+            <a:ext cx="5303520" cy="4937760"/>
           </a:xfrm>
           <a:prstGeom prst="rect">
             <a:avLst/>
@@ -6613,61 +6535,61 @@
           <a:p>
             <a:pPr>
               <a:spcAft>
-                <a:spcPts val="700"/>
+                <a:spcPts val="800"/>
               </a:spcAft>
               <a:defRPr sz="1900">
                 <a:solidFill>
-                  <a:srgbClr val="1E1E1E"/>
+                  <a:srgbClr val="232323"/>
                 </a:solidFill>
               </a:defRPr>
             </a:pPr>
             <a:r>
-              <a:t>Ausgangslage beschreiben</a:t>
+              <a:t>Kontrollstrukturen können ineinander liegen.</a:t>
             </a:r>
           </a:p>
           <a:p>
             <a:pPr>
               <a:spcAft>
-                <a:spcPts val="700"/>
+                <a:spcPts val="800"/>
               </a:spcAft>
               <a:defRPr sz="1900">
                 <a:solidFill>
-                  <a:srgbClr val="1E1E1E"/>
+                  <a:srgbClr val="232323"/>
                 </a:solidFill>
               </a:defRPr>
             </a:pPr>
             <a:r>
-              <a:t>erwartetes Ergebnis nennen</a:t>
+              <a:t>Beispiel: Schleife in Schleife.</a:t>
             </a:r>
           </a:p>
           <a:p>
             <a:pPr>
               <a:spcAft>
-                <a:spcPts val="700"/>
+                <a:spcPts val="800"/>
               </a:spcAft>
               <a:defRPr sz="1900">
                 <a:solidFill>
-                  <a:srgbClr val="1E1E1E"/>
+                  <a:srgbClr val="232323"/>
                 </a:solidFill>
               </a:defRPr>
             </a:pPr>
             <a:r>
-              <a:t>tatsächliches Ergebnis beobachten</a:t>
+              <a:t>Auch Bedingungen und Schleifen können miteinander verschachtelt werden.</a:t>
             </a:r>
           </a:p>
           <a:p>
             <a:pPr>
               <a:spcAft>
-                <a:spcPts val="700"/>
+                <a:spcPts val="800"/>
               </a:spcAft>
               <a:defRPr sz="1900">
                 <a:solidFill>
-                  <a:srgbClr val="1E1E1E"/>
+                  <a:srgbClr val="232323"/>
                 </a:solidFill>
               </a:defRPr>
             </a:pPr>
             <a:r>
-              <a:t>gezielt ändern und erneut testen</a:t>
+              <a:t>Einrückung macht die Struktur sichtbar.</a:t>
             </a:r>
           </a:p>
         </p:txBody>
@@ -6680,18 +6602,18 @@
         </p:nvSpPr>
         <p:spPr>
           <a:xfrm>
-            <a:off x="6766560" y="1463040"/>
-            <a:ext cx="1920240" cy="685800"/>
+            <a:off x="6217920" y="1188720"/>
+            <a:ext cx="5029200" cy="566928"/>
           </a:xfrm>
           <a:prstGeom prst="roundRect">
             <a:avLst/>
           </a:prstGeom>
           <a:solidFill>
-            <a:srgbClr val="FFE899"/>
+            <a:srgbClr val="DCE6F1"/>
           </a:solidFill>
           <a:ln>
             <a:solidFill>
-              <a:srgbClr val="305396"/>
+              <a:srgbClr val="4472C4"/>
             </a:solidFill>
           </a:ln>
         </p:spPr>
@@ -6717,10 +6639,10 @@
             <a:r>
               <a:rPr sz="1300" b="1">
                 <a:solidFill>
-                  <a:srgbClr val="202C3C"/>
+                  <a:srgbClr val="1F374E"/>
                 </a:solidFill>
               </a:rPr>
-              <a:t>Beobachten</a:t>
+              <a:t>4-mal wiederholen</a:t>
             </a:r>
           </a:p>
         </p:txBody>
@@ -6733,18 +6655,18 @@
         </p:nvSpPr>
         <p:spPr>
           <a:xfrm>
-            <a:off x="9326880" y="1463040"/>
-            <a:ext cx="1920240" cy="685800"/>
+            <a:off x="6537959" y="1828800"/>
+            <a:ext cx="4389120" cy="566928"/>
           </a:xfrm>
           <a:prstGeom prst="roundRect">
             <a:avLst/>
           </a:prstGeom>
           <a:solidFill>
-            <a:srgbClr val="E5ECF6"/>
+            <a:srgbClr val="F2F6FA"/>
           </a:solidFill>
           <a:ln>
             <a:solidFill>
-              <a:srgbClr val="305396"/>
+              <a:srgbClr val="4472C4"/>
             </a:solidFill>
           </a:ln>
         </p:spPr>
@@ -6770,10 +6692,10 @@
             <a:r>
               <a:rPr sz="1300" b="1">
                 <a:solidFill>
-                  <a:srgbClr val="202C3C"/>
+                  <a:srgbClr val="1F374E"/>
                 </a:solidFill>
               </a:rPr>
-              <a:t>Eingrenzen</a:t>
+              <a:t>4-mal wiederholen</a:t>
             </a:r>
           </a:p>
         </p:txBody>
@@ -6786,18 +6708,18 @@
         </p:nvSpPr>
         <p:spPr>
           <a:xfrm>
-            <a:off x="6766560" y="3383280"/>
-            <a:ext cx="1920240" cy="685800"/>
+            <a:off x="6858000" y="2468880"/>
+            <a:ext cx="3749039" cy="566928"/>
           </a:xfrm>
           <a:prstGeom prst="roundRect">
             <a:avLst/>
           </a:prstGeom>
           <a:solidFill>
-            <a:srgbClr val="FFE899"/>
+            <a:srgbClr val="FFE699"/>
           </a:solidFill>
           <a:ln>
             <a:solidFill>
-              <a:srgbClr val="305396"/>
+              <a:srgbClr val="4472C4"/>
             </a:solidFill>
           </a:ln>
         </p:spPr>
@@ -6823,10 +6745,10 @@
             <a:r>
               <a:rPr sz="1300" b="1">
                 <a:solidFill>
-                  <a:srgbClr val="202C3C"/>
+                  <a:srgbClr val="1F374E"/>
                 </a:solidFill>
               </a:rPr>
-              <a:t>Ändern</a:t>
+              <a:t>Ziegel hinlegen</a:t>
             </a:r>
           </a:p>
         </p:txBody>
@@ -6839,18 +6761,18 @@
         </p:nvSpPr>
         <p:spPr>
           <a:xfrm>
-            <a:off x="9326880" y="3383280"/>
-            <a:ext cx="1920240" cy="685800"/>
+            <a:off x="6858000" y="3108960"/>
+            <a:ext cx="3749039" cy="566928"/>
           </a:xfrm>
           <a:prstGeom prst="roundRect">
             <a:avLst/>
           </a:prstGeom>
           <a:solidFill>
-            <a:srgbClr val="E5ECF6"/>
+            <a:srgbClr val="FFE699"/>
           </a:solidFill>
           <a:ln>
             <a:solidFill>
-              <a:srgbClr val="305396"/>
+              <a:srgbClr val="4472C4"/>
             </a:solidFill>
           </a:ln>
         </p:spPr>
@@ -6876,10 +6798,10 @@
             <a:r>
               <a:rPr sz="1300" b="1">
                 <a:solidFill>
-                  <a:srgbClr val="202C3C"/>
+                  <a:srgbClr val="1F374E"/>
                 </a:solidFill>
               </a:rPr>
-              <a:t>Testen</a:t>
+              <a:t>Schritt</a:t>
             </a:r>
           </a:p>
         </p:txBody>
@@ -6892,18 +6814,18 @@
         </p:nvSpPr>
         <p:spPr>
           <a:xfrm>
-            <a:off x="7955279" y="2743200"/>
-            <a:ext cx="2011680" cy="594360"/>
+            <a:off x="6537959" y="3749040"/>
+            <a:ext cx="4389120" cy="566928"/>
           </a:xfrm>
           <a:prstGeom prst="roundRect">
             <a:avLst/>
           </a:prstGeom>
           <a:solidFill>
-            <a:srgbClr val="DDEEDD"/>
+            <a:srgbClr val="F2F6FA"/>
           </a:solidFill>
           <a:ln>
             <a:solidFill>
-              <a:srgbClr val="305396"/>
+              <a:srgbClr val="4472C4"/>
             </a:solidFill>
           </a:ln>
         </p:spPr>
@@ -6929,10 +6851,10 @@
             <a:r>
               <a:rPr sz="1300" b="1">
                 <a:solidFill>
-                  <a:srgbClr val="202C3C"/>
+                  <a:srgbClr val="1F374E"/>
                 </a:solidFill>
               </a:rPr>
-              <a:t>Debugging-Zyklus</a:t>
+              <a:t>drehen / Reihenwechsel</a:t>
             </a:r>
           </a:p>
         </p:txBody>
@@ -6945,8 +6867,8 @@
         </p:nvSpPr>
         <p:spPr>
           <a:xfrm>
-            <a:off x="365760" y="6510528"/>
-            <a:ext cx="11430000" cy="228600"/>
+            <a:off x="502920" y="6510528"/>
+            <a:ext cx="11064240" cy="182880"/>
           </a:xfrm>
           <a:prstGeom prst="rect">
             <a:avLst/>
@@ -6963,7 +6885,7 @@
             <a:r>
               <a:rPr sz="800">
                 <a:solidFill>
-                  <a:srgbClr val="6E6E6E"/>
+                  <a:srgbClr val="646464"/>
                 </a:solidFill>
               </a:rPr>
               <a:t>Grafik: eigene Darstellung</a:t>
@@ -6998,13 +6920,13 @@
         <p:spPr>
           <a:xfrm>
             <a:off x="0" y="0"/>
-            <a:ext cx="12191695" cy="109728"/>
+            <a:ext cx="12191695" cy="100584"/>
           </a:xfrm>
           <a:prstGeom prst="rect">
             <a:avLst/>
           </a:prstGeom>
           <a:solidFill>
-            <a:srgbClr val="305396"/>
+            <a:srgbClr val="4472C4"/>
           </a:solidFill>
           <a:ln>
             <a:noFill/>
@@ -7041,7 +6963,7 @@
         <p:spPr>
           <a:xfrm>
             <a:off x="594360" y="320040"/>
-            <a:ext cx="10972800" cy="548640"/>
+            <a:ext cx="10972800" cy="502920"/>
           </a:xfrm>
           <a:prstGeom prst="rect">
             <a:avLst/>
@@ -7057,10 +6979,10 @@
             <a:r>
               <a:rPr sz="2600" b="1">
                 <a:solidFill>
-                  <a:srgbClr val="202C3C"/>
+                  <a:srgbClr val="1F374E"/>
                 </a:solidFill>
               </a:rPr>
-              <a:t>Quellen</a:t>
+              <a:t>Testfälle konkret beschreiben</a:t>
             </a:r>
           </a:p>
         </p:txBody>
@@ -7074,7 +6996,7 @@
         <p:spPr>
           <a:xfrm>
             <a:off x="685800" y="1234440"/>
-            <a:ext cx="5394960" cy="5029200"/>
+            <a:ext cx="5303520" cy="4937760"/>
           </a:xfrm>
           <a:prstGeom prst="rect">
             <a:avLst/>
@@ -7089,45 +7011,341 @@
           <a:p>
             <a:pPr>
               <a:spcAft>
-                <a:spcPts val="700"/>
+                <a:spcPts val="800"/>
               </a:spcAft>
               <a:defRPr sz="1900">
                 <a:solidFill>
-                  <a:srgbClr val="1E1E1E"/>
+                  <a:srgbClr val="232323"/>
                 </a:solidFill>
               </a:defRPr>
             </a:pPr>
             <a:r>
-              <a:t>Sächsischer Lehrplan Oberschule Informatik, Klassenstufe 8: https://www.schulportal.sachsen.de/lplandb/lehrplan/514</a:t>
+              <a:t>Ausgangslage: z. B. Wand nach 3 Kacheln.</a:t>
             </a:r>
           </a:p>
           <a:p>
             <a:pPr>
               <a:spcAft>
-                <a:spcPts val="700"/>
+                <a:spcPts val="800"/>
               </a:spcAft>
               <a:defRPr sz="1900">
                 <a:solidFill>
-                  <a:srgbClr val="1E1E1E"/>
+                  <a:srgbClr val="232323"/>
                 </a:solidFill>
               </a:defRPr>
             </a:pPr>
             <a:r>
-              <a:t>Struktogramme und Beispiele: eigene Darstellung.</a:t>
-            </a:r>
-          </a:p>
-        </p:txBody>
-      </p:sp>
-      <p:sp>
-        <p:nvSpPr>
-          <p:cNvPr id="5" name="TextBox 4"/>
+              <a:t>Erwartung: Karol bleibt vor der Wand stehen.</a:t>
+            </a:r>
+          </a:p>
+          <a:p>
+            <a:pPr>
+              <a:spcAft>
+                <a:spcPts val="800"/>
+              </a:spcAft>
+              <a:defRPr sz="1900">
+                <a:solidFill>
+                  <a:srgbClr val="232323"/>
+                </a:solidFill>
+              </a:defRPr>
+            </a:pPr>
+            <a:r>
+              <a:t>Beobachtung: Was passiert tatsächlich?</a:t>
+            </a:r>
+          </a:p>
+          <a:p>
+            <a:pPr>
+              <a:spcAft>
+                <a:spcPts val="800"/>
+              </a:spcAft>
+              <a:defRPr sz="1900">
+                <a:solidFill>
+                  <a:srgbClr val="232323"/>
+                </a:solidFill>
+              </a:defRPr>
+            </a:pPr>
+            <a:r>
+              <a:t>Änderung: gezielt nur eine Ursache prüfen.</a:t>
+            </a:r>
+          </a:p>
+        </p:txBody>
+      </p:sp>
+      <p:sp>
+        <p:nvSpPr>
+          <p:cNvPr id="5" name="Rounded Rectangle 4"/>
+          <p:cNvSpPr/>
+          <p:nvPr/>
+        </p:nvSpPr>
+        <p:spPr>
+          <a:xfrm>
+            <a:off x="8001000" y="1051560"/>
+            <a:ext cx="1463040" cy="548640"/>
+          </a:xfrm>
+          <a:prstGeom prst="roundRect">
+            <a:avLst/>
+          </a:prstGeom>
+          <a:solidFill>
+            <a:srgbClr val="FFE699"/>
+          </a:solidFill>
+          <a:ln>
+            <a:solidFill>
+              <a:srgbClr val="4472C4"/>
+            </a:solidFill>
+          </a:ln>
+        </p:spPr>
+        <p:style>
+          <a:lnRef idx="1">
+            <a:schemeClr val="accent1"/>
+          </a:lnRef>
+          <a:fillRef idx="3">
+            <a:schemeClr val="accent1"/>
+          </a:fillRef>
+          <a:effectRef idx="2">
+            <a:schemeClr val="accent1"/>
+          </a:effectRef>
+          <a:fontRef idx="minor">
+            <a:schemeClr val="lt1"/>
+          </a:fontRef>
+        </p:style>
+        <p:txBody>
+          <a:bodyPr rtlCol="0" anchor="ctr" wrap="square"/>
+          <a:lstStyle/>
+          <a:p>
+            <a:pPr algn="ctr"/>
+            <a:r>
+              <a:rPr sz="1200" b="1">
+                <a:solidFill>
+                  <a:srgbClr val="1F374E"/>
+                </a:solidFill>
+              </a:rPr>
+              <a:t>Beobachten</a:t>
+            </a:r>
+          </a:p>
+        </p:txBody>
+      </p:sp>
+      <p:sp>
+        <p:nvSpPr>
+          <p:cNvPr id="6" name="Rounded Rectangle 5"/>
+          <p:cNvSpPr/>
+          <p:nvPr/>
+        </p:nvSpPr>
+        <p:spPr>
+          <a:xfrm>
+            <a:off x="9326880" y="2560320"/>
+            <a:ext cx="1463040" cy="548640"/>
+          </a:xfrm>
+          <a:prstGeom prst="roundRect">
+            <a:avLst/>
+          </a:prstGeom>
+          <a:solidFill>
+            <a:srgbClr val="F2F6FA"/>
+          </a:solidFill>
+          <a:ln>
+            <a:solidFill>
+              <a:srgbClr val="4472C4"/>
+            </a:solidFill>
+          </a:ln>
+        </p:spPr>
+        <p:style>
+          <a:lnRef idx="1">
+            <a:schemeClr val="accent1"/>
+          </a:lnRef>
+          <a:fillRef idx="3">
+            <a:schemeClr val="accent1"/>
+          </a:fillRef>
+          <a:effectRef idx="2">
+            <a:schemeClr val="accent1"/>
+          </a:effectRef>
+          <a:fontRef idx="minor">
+            <a:schemeClr val="lt1"/>
+          </a:fontRef>
+        </p:style>
+        <p:txBody>
+          <a:bodyPr rtlCol="0" anchor="ctr" wrap="square"/>
+          <a:lstStyle/>
+          <a:p>
+            <a:pPr algn="ctr"/>
+            <a:r>
+              <a:rPr sz="1200" b="1">
+                <a:solidFill>
+                  <a:srgbClr val="1F374E"/>
+                </a:solidFill>
+              </a:rPr>
+              <a:t>Eingrenzen</a:t>
+            </a:r>
+          </a:p>
+        </p:txBody>
+      </p:sp>
+      <p:sp>
+        <p:nvSpPr>
+          <p:cNvPr id="7" name="Rounded Rectangle 6"/>
+          <p:cNvSpPr/>
+          <p:nvPr/>
+        </p:nvSpPr>
+        <p:spPr>
+          <a:xfrm>
+            <a:off x="8001000" y="4069080"/>
+            <a:ext cx="1463040" cy="548640"/>
+          </a:xfrm>
+          <a:prstGeom prst="roundRect">
+            <a:avLst/>
+          </a:prstGeom>
+          <a:solidFill>
+            <a:srgbClr val="FFE699"/>
+          </a:solidFill>
+          <a:ln>
+            <a:solidFill>
+              <a:srgbClr val="4472C4"/>
+            </a:solidFill>
+          </a:ln>
+        </p:spPr>
+        <p:style>
+          <a:lnRef idx="1">
+            <a:schemeClr val="accent1"/>
+          </a:lnRef>
+          <a:fillRef idx="3">
+            <a:schemeClr val="accent1"/>
+          </a:fillRef>
+          <a:effectRef idx="2">
+            <a:schemeClr val="accent1"/>
+          </a:effectRef>
+          <a:fontRef idx="minor">
+            <a:schemeClr val="lt1"/>
+          </a:fontRef>
+        </p:style>
+        <p:txBody>
+          <a:bodyPr rtlCol="0" anchor="ctr" wrap="square"/>
+          <a:lstStyle/>
+          <a:p>
+            <a:pPr algn="ctr"/>
+            <a:r>
+              <a:rPr sz="1200" b="1">
+                <a:solidFill>
+                  <a:srgbClr val="1F374E"/>
+                </a:solidFill>
+              </a:rPr>
+              <a:t>Ändern</a:t>
+            </a:r>
+          </a:p>
+        </p:txBody>
+      </p:sp>
+      <p:sp>
+        <p:nvSpPr>
+          <p:cNvPr id="8" name="Rounded Rectangle 7"/>
+          <p:cNvSpPr/>
+          <p:nvPr/>
+        </p:nvSpPr>
+        <p:spPr>
+          <a:xfrm>
+            <a:off x="6583680" y="2560320"/>
+            <a:ext cx="1463040" cy="548640"/>
+          </a:xfrm>
+          <a:prstGeom prst="roundRect">
+            <a:avLst/>
+          </a:prstGeom>
+          <a:solidFill>
+            <a:srgbClr val="F2F6FA"/>
+          </a:solidFill>
+          <a:ln>
+            <a:solidFill>
+              <a:srgbClr val="4472C4"/>
+            </a:solidFill>
+          </a:ln>
+        </p:spPr>
+        <p:style>
+          <a:lnRef idx="1">
+            <a:schemeClr val="accent1"/>
+          </a:lnRef>
+          <a:fillRef idx="3">
+            <a:schemeClr val="accent1"/>
+          </a:fillRef>
+          <a:effectRef idx="2">
+            <a:schemeClr val="accent1"/>
+          </a:effectRef>
+          <a:fontRef idx="minor">
+            <a:schemeClr val="lt1"/>
+          </a:fontRef>
+        </p:style>
+        <p:txBody>
+          <a:bodyPr rtlCol="0" anchor="ctr" wrap="square"/>
+          <a:lstStyle/>
+          <a:p>
+            <a:pPr algn="ctr"/>
+            <a:r>
+              <a:rPr sz="1200" b="1">
+                <a:solidFill>
+                  <a:srgbClr val="1F374E"/>
+                </a:solidFill>
+              </a:rPr>
+              <a:t>Testen</a:t>
+            </a:r>
+          </a:p>
+        </p:txBody>
+      </p:sp>
+      <p:sp>
+        <p:nvSpPr>
+          <p:cNvPr id="9" name="Rounded Rectangle 8"/>
+          <p:cNvSpPr/>
+          <p:nvPr/>
+        </p:nvSpPr>
+        <p:spPr>
+          <a:xfrm>
+            <a:off x="7909560" y="2514600"/>
+            <a:ext cx="1645920" cy="640080"/>
+          </a:xfrm>
+          <a:prstGeom prst="roundRect">
+            <a:avLst/>
+          </a:prstGeom>
+          <a:solidFill>
+            <a:srgbClr val="E2EFDA"/>
+          </a:solidFill>
+          <a:ln>
+            <a:solidFill>
+              <a:srgbClr val="4472C4"/>
+            </a:solidFill>
+          </a:ln>
+        </p:spPr>
+        <p:style>
+          <a:lnRef idx="1">
+            <a:schemeClr val="accent1"/>
+          </a:lnRef>
+          <a:fillRef idx="3">
+            <a:schemeClr val="accent1"/>
+          </a:fillRef>
+          <a:effectRef idx="2">
+            <a:schemeClr val="accent1"/>
+          </a:effectRef>
+          <a:fontRef idx="minor">
+            <a:schemeClr val="lt1"/>
+          </a:fontRef>
+        </p:style>
+        <p:txBody>
+          <a:bodyPr rtlCol="0" anchor="ctr" wrap="square"/>
+          <a:lstStyle/>
+          <a:p>
+            <a:pPr algn="ctr"/>
+            <a:r>
+              <a:rPr sz="1300" b="1">
+                <a:solidFill>
+                  <a:srgbClr val="1F374E"/>
+                </a:solidFill>
+              </a:rPr>
+              <a:t>Programm
+verbessern</a:t>
+            </a:r>
+          </a:p>
+        </p:txBody>
+      </p:sp>
+      <p:sp>
+        <p:nvSpPr>
+          <p:cNvPr id="10" name="TextBox 9"/>
           <p:cNvSpPr txBox="1"/>
           <p:nvPr/>
         </p:nvSpPr>
         <p:spPr>
           <a:xfrm>
-            <a:off x="365760" y="6510528"/>
-            <a:ext cx="11430000" cy="228600"/>
+            <a:off x="502920" y="6510528"/>
+            <a:ext cx="11064240" cy="182880"/>
           </a:xfrm>
           <a:prstGeom prst="rect">
             <a:avLst/>
@@ -7144,10 +7362,10 @@
             <a:r>
               <a:rPr sz="800">
                 <a:solidFill>
-                  <a:srgbClr val="6E6E6E"/>
+                  <a:srgbClr val="646464"/>
                 </a:solidFill>
               </a:rPr>
-              <a:t>Quellenangaben · Grafiken: eigene Darstellung</a:t>
+              <a:t>Grafik: eigene Darstellung</a:t>
             </a:r>
           </a:p>
         </p:txBody>

</xml_diff>